<commit_message>
modified:   presentation/image_captioning_presentation.pptx 	modified:   projects/image_captioning/flickr8k_eda_step_by_step.ipynb 	modified:   projects/image_captioning/flickr8k_modeling_step_by_step.ipynb
</commit_message>
<xml_diff>
--- a/presentation/image_captioning_presentation.pptx
+++ b/presentation/image_captioning_presentation.pptx
@@ -18,8 +18,10 @@
     <p:sldId id="266" r:id="rId17"/>
     <p:sldId id="267" r:id="rId18"/>
     <p:sldId id="268" r:id="rId19"/>
+    <p:sldId id="269" r:id="rId20"/>
+    <p:sldId id="270" r:id="rId21"/>
   </p:sldIdLst>
-  <p:sldSz cx="9144000" cy="6858000" type="screen4x3"/>
+  <p:sldSz cx="12192000" cy="6858000" type="screen4x3"/>
   <p:notesSz cx="6858000" cy="9144000"/>
   <p:defaultTextStyle>
     <a:defPPr>
@@ -3102,42 +3104,256 @@
       <p:grpSpPr/>
       <p:sp>
         <p:nvSpPr>
-          <p:cNvPr id="2" name="Title 1"/>
-          <p:cNvSpPr>
-            <a:spLocks noGrp="1"/>
-          </p:cNvSpPr>
-          <p:nvPr>
-            <p:ph type="ctrTitle"/>
-          </p:nvPr>
-        </p:nvSpPr>
-        <p:spPr/>
-        <p:txBody>
-          <a:bodyPr/>
-          <a:lstStyle/>
-          <a:p>
-            <a:r>
-              <a:t>Слайд 1: Тема и цел</a:t>
-            </a:r>
-          </a:p>
-        </p:txBody>
-      </p:sp>
-      <p:sp>
-        <p:nvSpPr>
-          <p:cNvPr id="3" name="Subtitle 2"/>
-          <p:cNvSpPr>
-            <a:spLocks noGrp="1"/>
-          </p:cNvSpPr>
-          <p:nvPr>
-            <p:ph type="subTitle" idx="1"/>
-          </p:nvPr>
-        </p:nvSpPr>
-        <p:spPr/>
-        <p:txBody>
-          <a:bodyPr/>
-          <a:lstStyle/>
-          <a:p>
-            <a:r>
-              <a:t>Flickr8k image captioning project</a:t>
+          <p:cNvPr id="2" name="TextBox 1"/>
+          <p:cNvSpPr txBox="1"/>
+          <p:nvPr/>
+        </p:nvSpPr>
+        <p:spPr>
+          <a:xfrm>
+            <a:off x="594360" y="320040"/>
+            <a:ext cx="10972800" cy="365760"/>
+          </a:xfrm>
+          <a:prstGeom prst="rect">
+            <a:avLst/>
+          </a:prstGeom>
+          <a:noFill/>
+        </p:spPr>
+        <p:txBody>
+          <a:bodyPr wrap="none">
+            <a:spAutoFit/>
+          </a:bodyPr>
+          <a:lstStyle/>
+          <a:p>
+            <a:pPr algn="ctr"/>
+            <a:r>
+              <a:rPr sz="2100" b="0" i="0">
+                <a:latin typeface="Calibri"/>
+              </a:rPr>
+              <a:t>Софийски университет „Св. Климент Охридски“</a:t>
+            </a:r>
+          </a:p>
+        </p:txBody>
+      </p:sp>
+      <p:sp>
+        <p:nvSpPr>
+          <p:cNvPr id="3" name="TextBox 2"/>
+          <p:cNvSpPr txBox="1"/>
+          <p:nvPr/>
+        </p:nvSpPr>
+        <p:spPr>
+          <a:xfrm>
+            <a:off x="1097280" y="1508760"/>
+            <a:ext cx="10058400" cy="960120"/>
+          </a:xfrm>
+          <a:prstGeom prst="rect">
+            <a:avLst/>
+          </a:prstGeom>
+          <a:noFill/>
+        </p:spPr>
+        <p:txBody>
+          <a:bodyPr wrap="none">
+            <a:spAutoFit/>
+          </a:bodyPr>
+          <a:lstStyle/>
+          <a:p>
+            <a:pPr algn="ctr"/>
+            <a:r>
+              <a:rPr sz="3600" b="1" i="0">
+                <a:latin typeface="Calibri"/>
+              </a:rPr>
+              <a:t>Генериране на описание за изображение</a:t>
+            </a:r>
+          </a:p>
+        </p:txBody>
+      </p:sp>
+      <p:sp>
+        <p:nvSpPr>
+          <p:cNvPr id="4" name="TextBox 3"/>
+          <p:cNvSpPr txBox="1"/>
+          <p:nvPr/>
+        </p:nvSpPr>
+        <p:spPr>
+          <a:xfrm>
+            <a:off x="3566160" y="2743200"/>
+            <a:ext cx="5029200" cy="502920"/>
+          </a:xfrm>
+          <a:prstGeom prst="rect">
+            <a:avLst/>
+          </a:prstGeom>
+          <a:noFill/>
+        </p:spPr>
+        <p:txBody>
+          <a:bodyPr wrap="none">
+            <a:spAutoFit/>
+          </a:bodyPr>
+          <a:lstStyle/>
+          <a:p>
+            <a:pPr algn="ctr"/>
+            <a:r>
+              <a:rPr sz="3000" b="1" i="0">
+                <a:latin typeface="Calibri"/>
+              </a:rPr>
+              <a:t>Курсов проект</a:t>
+            </a:r>
+          </a:p>
+        </p:txBody>
+      </p:sp>
+      <p:sp>
+        <p:nvSpPr>
+          <p:cNvPr id="5" name="TextBox 4"/>
+          <p:cNvSpPr txBox="1"/>
+          <p:nvPr/>
+        </p:nvSpPr>
+        <p:spPr>
+          <a:xfrm>
+            <a:off x="2743200" y="4343400"/>
+            <a:ext cx="6766560" cy="274320"/>
+          </a:xfrm>
+          <a:prstGeom prst="rect">
+            <a:avLst/>
+          </a:prstGeom>
+          <a:noFill/>
+        </p:spPr>
+        <p:txBody>
+          <a:bodyPr wrap="none">
+            <a:spAutoFit/>
+          </a:bodyPr>
+          <a:lstStyle/>
+          <a:p>
+            <a:pPr algn="ctr"/>
+            <a:r>
+              <a:rPr sz="1600" b="0" i="1">
+                <a:latin typeface="Calibri"/>
+              </a:rPr>
+              <a:t>Факултет по математика и информатика</a:t>
+            </a:r>
+          </a:p>
+        </p:txBody>
+      </p:sp>
+      <p:sp>
+        <p:nvSpPr>
+          <p:cNvPr id="6" name="TextBox 5"/>
+          <p:cNvSpPr txBox="1"/>
+          <p:nvPr/>
+        </p:nvSpPr>
+        <p:spPr>
+          <a:xfrm>
+            <a:off x="2743200" y="4663440"/>
+            <a:ext cx="6766560" cy="274320"/>
+          </a:xfrm>
+          <a:prstGeom prst="rect">
+            <a:avLst/>
+          </a:prstGeom>
+          <a:noFill/>
+        </p:spPr>
+        <p:txBody>
+          <a:bodyPr wrap="none">
+            <a:spAutoFit/>
+          </a:bodyPr>
+          <a:lstStyle/>
+          <a:p>
+            <a:pPr algn="ctr"/>
+            <a:r>
+              <a:rPr sz="1600" b="0" i="1">
+                <a:latin typeface="Calibri"/>
+              </a:rPr>
+              <a:t>Студент: Никола</a:t>
+            </a:r>
+          </a:p>
+        </p:txBody>
+      </p:sp>
+      <p:sp>
+        <p:nvSpPr>
+          <p:cNvPr id="7" name="TextBox 6"/>
+          <p:cNvSpPr txBox="1"/>
+          <p:nvPr/>
+        </p:nvSpPr>
+        <p:spPr>
+          <a:xfrm>
+            <a:off x="2743200" y="4983480"/>
+            <a:ext cx="6766560" cy="274320"/>
+          </a:xfrm>
+          <a:prstGeom prst="rect">
+            <a:avLst/>
+          </a:prstGeom>
+          <a:noFill/>
+        </p:spPr>
+        <p:txBody>
+          <a:bodyPr wrap="none">
+            <a:spAutoFit/>
+          </a:bodyPr>
+          <a:lstStyle/>
+          <a:p>
+            <a:pPr algn="ctr"/>
+            <a:r>
+              <a:rPr sz="1600" b="0" i="1">
+                <a:latin typeface="Calibri"/>
+              </a:rPr>
+              <a:t>Факултетен номер: [попълва се]</a:t>
+            </a:r>
+          </a:p>
+        </p:txBody>
+      </p:sp>
+      <p:sp>
+        <p:nvSpPr>
+          <p:cNvPr id="8" name="TextBox 7"/>
+          <p:cNvSpPr txBox="1"/>
+          <p:nvPr/>
+        </p:nvSpPr>
+        <p:spPr>
+          <a:xfrm>
+            <a:off x="2743200" y="5303520"/>
+            <a:ext cx="6766560" cy="274320"/>
+          </a:xfrm>
+          <a:prstGeom prst="rect">
+            <a:avLst/>
+          </a:prstGeom>
+          <a:noFill/>
+        </p:spPr>
+        <p:txBody>
+          <a:bodyPr wrap="none">
+            <a:spAutoFit/>
+          </a:bodyPr>
+          <a:lstStyle/>
+          <a:p>
+            <a:pPr algn="ctr"/>
+            <a:r>
+              <a:rPr sz="1600" b="0" i="1">
+                <a:latin typeface="Calibri"/>
+              </a:rPr>
+              <a:t>Учебен план: Изкуствен интелект</a:t>
+            </a:r>
+          </a:p>
+        </p:txBody>
+      </p:sp>
+      <p:sp>
+        <p:nvSpPr>
+          <p:cNvPr id="9" name="TextBox 8"/>
+          <p:cNvSpPr txBox="1"/>
+          <p:nvPr/>
+        </p:nvSpPr>
+        <p:spPr>
+          <a:xfrm>
+            <a:off x="2743200" y="5623560"/>
+            <a:ext cx="6766560" cy="274320"/>
+          </a:xfrm>
+          <a:prstGeom prst="rect">
+            <a:avLst/>
+          </a:prstGeom>
+          <a:noFill/>
+        </p:spPr>
+        <p:txBody>
+          <a:bodyPr wrap="none">
+            <a:spAutoFit/>
+          </a:bodyPr>
+          <a:lstStyle/>
+          <a:p>
+            <a:pPr algn="ctr"/>
+            <a:r>
+              <a:rPr sz="1600" b="0" i="1">
+                <a:latin typeface="Calibri"/>
+              </a:rPr>
+              <a:t>Дисциплина: Дълбоко обучение</a:t>
             </a:r>
           </a:p>
         </p:txBody>
@@ -3162,77 +3378,216 @@
       <p:grpSpPr/>
       <p:sp>
         <p:nvSpPr>
-          <p:cNvPr id="2" name="Title 1"/>
-          <p:cNvSpPr>
-            <a:spLocks noGrp="1"/>
-          </p:cNvSpPr>
-          <p:nvPr>
-            <p:ph type="title"/>
-          </p:nvPr>
-        </p:nvSpPr>
-        <p:spPr/>
-        <p:txBody>
-          <a:bodyPr/>
-          <a:lstStyle/>
-          <a:p>
-            <a:r>
-              <a:t>Слайд 10: Streamlit приложение</a:t>
-            </a:r>
-          </a:p>
-        </p:txBody>
-      </p:sp>
-      <p:sp>
-        <p:nvSpPr>
-          <p:cNvPr id="3" name="Content Placeholder 2"/>
-          <p:cNvSpPr>
-            <a:spLocks noGrp="1"/>
-          </p:cNvSpPr>
-          <p:nvPr>
-            <p:ph idx="1"/>
-          </p:nvPr>
-        </p:nvSpPr>
-        <p:spPr/>
-        <p:txBody>
-          <a:bodyPr/>
+          <p:cNvPr id="2" name="TextBox 1"/>
+          <p:cNvSpPr txBox="1"/>
+          <p:nvPr/>
+        </p:nvSpPr>
+        <p:spPr>
+          <a:xfrm>
+            <a:off x="640080" y="411480"/>
+            <a:ext cx="10972800" cy="502920"/>
+          </a:xfrm>
+          <a:prstGeom prst="rect">
+            <a:avLst/>
+          </a:prstGeom>
+          <a:noFill/>
+        </p:spPr>
+        <p:txBody>
+          <a:bodyPr wrap="none">
+            <a:spAutoFit/>
+          </a:bodyPr>
+          <a:lstStyle/>
+          <a:p>
+            <a:pPr algn="l"/>
+            <a:r>
+              <a:rPr sz="2600" b="1" i="0">
+                <a:latin typeface="Calibri"/>
+              </a:rPr>
+              <a:t>Експерименти</a:t>
+            </a:r>
+          </a:p>
+        </p:txBody>
+      </p:sp>
+      <p:sp>
+        <p:nvSpPr>
+          <p:cNvPr id="3" name="Rectangle 2"/>
+          <p:cNvSpPr/>
+          <p:nvPr/>
+        </p:nvSpPr>
+        <p:spPr>
+          <a:xfrm>
+            <a:off x="640080" y="1005840"/>
+            <a:ext cx="10881360" cy="9144"/>
+          </a:xfrm>
+          <a:prstGeom prst="rect">
+            <a:avLst/>
+          </a:prstGeom>
+          <a:solidFill>
+            <a:srgbClr val="000000"/>
+          </a:solidFill>
+          <a:ln>
+            <a:solidFill>
+              <a:srgbClr val="000000"/>
+            </a:solidFill>
+          </a:ln>
+        </p:spPr>
+        <p:style>
+          <a:lnRef idx="1">
+            <a:schemeClr val="accent1"/>
+          </a:lnRef>
+          <a:fillRef idx="3">
+            <a:schemeClr val="accent1"/>
+          </a:fillRef>
+          <a:effectRef idx="2">
+            <a:schemeClr val="accent1"/>
+          </a:effectRef>
+          <a:fontRef idx="minor">
+            <a:schemeClr val="lt1"/>
+          </a:fontRef>
+        </p:style>
+        <p:txBody>
+          <a:bodyPr rtlCol="0" anchor="ctr"/>
+          <a:lstStyle/>
+          <a:p>
+            <a:pPr algn="ctr"/>
+          </a:p>
+        </p:txBody>
+      </p:sp>
+      <p:sp>
+        <p:nvSpPr>
+          <p:cNvPr id="4" name="TextBox 3"/>
+          <p:cNvSpPr txBox="1"/>
+          <p:nvPr/>
+        </p:nvSpPr>
+        <p:spPr>
+          <a:xfrm>
+            <a:off x="868680" y="1325880"/>
+            <a:ext cx="10424160" cy="4754880"/>
+          </a:xfrm>
+          <a:prstGeom prst="rect">
+            <a:avLst/>
+          </a:prstGeom>
+          <a:noFill/>
+        </p:spPr>
+        <p:txBody>
+          <a:bodyPr wrap="square">
+            <a:spAutoFit/>
+          </a:bodyPr>
           <a:lstStyle/>
           <a:p>
             <a:pPr>
-              <a:defRPr sz="2400"/>
+              <a:spcAft>
+                <a:spcPts val="1000"/>
+              </a:spcAft>
+              <a:defRPr sz="2100">
+                <a:latin typeface="Calibri"/>
+              </a:defRPr>
             </a:pPr>
             <a:r>
-              <a:t>Потребителят качва изображение.</a:t>
+              <a:t>Тествани са различни настройки на LSTM hidden size и dropout.</a:t>
             </a:r>
           </a:p>
           <a:p>
             <a:pPr>
-              <a:defRPr sz="2400"/>
+              <a:spcAft>
+                <a:spcPts val="1000"/>
+              </a:spcAft>
+              <a:defRPr sz="2100">
+                <a:latin typeface="Calibri"/>
+              </a:defRPr>
             </a:pPr>
             <a:r>
-              <a:t>Моделът генерира caption.</a:t>
+              <a:t>Направен е TF-IDF експеримент върху captions за анализ на важните думи.</a:t>
             </a:r>
           </a:p>
           <a:p>
             <a:pPr>
-              <a:defRPr sz="2400"/>
+              <a:spcAft>
+                <a:spcPts val="1000"/>
+              </a:spcAft>
+              <a:defRPr sz="2100">
+                <a:latin typeface="Calibri"/>
+              </a:defRPr>
             </a:pPr>
             <a:r>
-              <a:t>Има три режима: VGG retrieval, VGG16 + LSTM и pretrained BLIP.</a:t>
+              <a:t>Добавен е VGG retrieval подход, който избира описание от визуално близки training изображения.</a:t>
             </a:r>
           </a:p>
           <a:p>
             <a:pPr>
-              <a:defRPr sz="2400"/>
+              <a:spcAft>
+                <a:spcPts val="1000"/>
+              </a:spcAft>
+              <a:defRPr sz="2100">
+                <a:latin typeface="Calibri"/>
+              </a:defRPr>
             </a:pPr>
             <a:r>
-              <a:t>Project baseline зарежда checkpoint от `checkpoints/best_model.pt`.</a:t>
-            </a:r>
-          </a:p>
-          <a:p>
-            <a:pPr>
-              <a:defRPr sz="2400"/>
-            </a:pPr>
-            <a:r>
-              <a:t>Използвам greedy и beam search режим за VGG16 + LSTM модела.</a:t>
+              <a:t>Сравнен е и режим с предварително обучен BLIP модел като по-силен ориентир.</a:t>
+            </a:r>
+          </a:p>
+        </p:txBody>
+      </p:sp>
+      <p:sp>
+        <p:nvSpPr>
+          <p:cNvPr id="5" name="TextBox 4"/>
+          <p:cNvSpPr txBox="1"/>
+          <p:nvPr/>
+        </p:nvSpPr>
+        <p:spPr>
+          <a:xfrm>
+            <a:off x="548640" y="6473952"/>
+            <a:ext cx="5486400" cy="228600"/>
+          </a:xfrm>
+          <a:prstGeom prst="rect">
+            <a:avLst/>
+          </a:prstGeom>
+          <a:noFill/>
+        </p:spPr>
+        <p:txBody>
+          <a:bodyPr wrap="none">
+            <a:spAutoFit/>
+          </a:bodyPr>
+          <a:lstStyle/>
+          <a:p>
+            <a:pPr algn="l"/>
+            <a:r>
+              <a:rPr sz="800" b="0" i="1">
+                <a:latin typeface="Calibri"/>
+              </a:rPr>
+              <a:t>Генериране на описание за изображение</a:t>
+            </a:r>
+          </a:p>
+        </p:txBody>
+      </p:sp>
+      <p:sp>
+        <p:nvSpPr>
+          <p:cNvPr id="6" name="TextBox 5"/>
+          <p:cNvSpPr txBox="1"/>
+          <p:nvPr/>
+        </p:nvSpPr>
+        <p:spPr>
+          <a:xfrm>
+            <a:off x="10972800" y="6473952"/>
+            <a:ext cx="640080" cy="228600"/>
+          </a:xfrm>
+          <a:prstGeom prst="rect">
+            <a:avLst/>
+          </a:prstGeom>
+          <a:noFill/>
+        </p:spPr>
+        <p:txBody>
+          <a:bodyPr wrap="none">
+            <a:spAutoFit/>
+          </a:bodyPr>
+          <a:lstStyle/>
+          <a:p>
+            <a:pPr algn="r"/>
+            <a:r>
+              <a:rPr sz="800" b="0" i="0">
+                <a:latin typeface="Calibri"/>
+              </a:rPr>
+              <a:t>10/15</a:t>
             </a:r>
           </a:p>
         </p:txBody>
@@ -3257,61 +3612,242 @@
       <p:grpSpPr/>
       <p:sp>
         <p:nvSpPr>
-          <p:cNvPr id="2" name="Title 1"/>
-          <p:cNvSpPr>
-            <a:spLocks noGrp="1"/>
-          </p:cNvSpPr>
-          <p:nvPr>
-            <p:ph type="title"/>
-          </p:nvPr>
-        </p:nvSpPr>
-        <p:spPr/>
-        <p:txBody>
-          <a:bodyPr/>
-          <a:lstStyle/>
-          <a:p>
-            <a:r>
-              <a:t>Слайд 11: Тестове</a:t>
-            </a:r>
-          </a:p>
-        </p:txBody>
-      </p:sp>
-      <p:sp>
-        <p:nvSpPr>
-          <p:cNvPr id="3" name="Content Placeholder 2"/>
-          <p:cNvSpPr>
-            <a:spLocks noGrp="1"/>
-          </p:cNvSpPr>
-          <p:nvPr>
-            <p:ph idx="1"/>
-          </p:nvPr>
-        </p:nvSpPr>
-        <p:spPr/>
-        <p:txBody>
-          <a:bodyPr/>
+          <p:cNvPr id="2" name="TextBox 1"/>
+          <p:cNvSpPr txBox="1"/>
+          <p:nvPr/>
+        </p:nvSpPr>
+        <p:spPr>
+          <a:xfrm>
+            <a:off x="640080" y="411480"/>
+            <a:ext cx="10972800" cy="502920"/>
+          </a:xfrm>
+          <a:prstGeom prst="rect">
+            <a:avLst/>
+          </a:prstGeom>
+          <a:noFill/>
+        </p:spPr>
+        <p:txBody>
+          <a:bodyPr wrap="none">
+            <a:spAutoFit/>
+          </a:bodyPr>
+          <a:lstStyle/>
+          <a:p>
+            <a:pPr algn="l"/>
+            <a:r>
+              <a:rPr sz="2600" b="1" i="0">
+                <a:latin typeface="Calibri"/>
+              </a:rPr>
+              <a:t>Резултати от основния модел</a:t>
+            </a:r>
+          </a:p>
+        </p:txBody>
+      </p:sp>
+      <p:sp>
+        <p:nvSpPr>
+          <p:cNvPr id="3" name="Rectangle 2"/>
+          <p:cNvSpPr/>
+          <p:nvPr/>
+        </p:nvSpPr>
+        <p:spPr>
+          <a:xfrm>
+            <a:off x="640080" y="1005840"/>
+            <a:ext cx="10881360" cy="9144"/>
+          </a:xfrm>
+          <a:prstGeom prst="rect">
+            <a:avLst/>
+          </a:prstGeom>
+          <a:solidFill>
+            <a:srgbClr val="000000"/>
+          </a:solidFill>
+          <a:ln>
+            <a:solidFill>
+              <a:srgbClr val="000000"/>
+            </a:solidFill>
+          </a:ln>
+        </p:spPr>
+        <p:style>
+          <a:lnRef idx="1">
+            <a:schemeClr val="accent1"/>
+          </a:lnRef>
+          <a:fillRef idx="3">
+            <a:schemeClr val="accent1"/>
+          </a:fillRef>
+          <a:effectRef idx="2">
+            <a:schemeClr val="accent1"/>
+          </a:effectRef>
+          <a:fontRef idx="minor">
+            <a:schemeClr val="lt1"/>
+          </a:fontRef>
+        </p:style>
+        <p:txBody>
+          <a:bodyPr rtlCol="0" anchor="ctr"/>
+          <a:lstStyle/>
+          <a:p>
+            <a:pPr algn="ctr"/>
+          </a:p>
+        </p:txBody>
+      </p:sp>
+      <p:sp>
+        <p:nvSpPr>
+          <p:cNvPr id="4" name="TextBox 3"/>
+          <p:cNvSpPr txBox="1"/>
+          <p:nvPr/>
+        </p:nvSpPr>
+        <p:spPr>
+          <a:xfrm>
+            <a:off x="868680" y="1325880"/>
+            <a:ext cx="10424160" cy="4754880"/>
+          </a:xfrm>
+          <a:prstGeom prst="rect">
+            <a:avLst/>
+          </a:prstGeom>
+          <a:noFill/>
+        </p:spPr>
+        <p:txBody>
+          <a:bodyPr wrap="square">
+            <a:spAutoFit/>
+          </a:bodyPr>
           <a:lstStyle/>
           <a:p>
             <a:pPr>
-              <a:defRPr sz="2400"/>
+              <a:spcAft>
+                <a:spcPts val="1000"/>
+              </a:spcAft>
+              <a:defRPr sz="2100">
+                <a:latin typeface="Calibri"/>
+              </a:defRPr>
             </a:pPr>
             <a:r>
-              <a:t>Написани са тестове за vocabulary, dataset, model, training и evaluation.</a:t>
+              <a:t>Validation loss: 2.7857.</a:t>
             </a:r>
           </a:p>
           <a:p>
             <a:pPr>
-              <a:defRPr sz="2400"/>
+              <a:spcAft>
+                <a:spcPts val="1000"/>
+              </a:spcAft>
+              <a:defRPr sz="2100">
+                <a:latin typeface="Calibri"/>
+              </a:defRPr>
             </a:pPr>
             <a:r>
-              <a:t>Има тестове за retrieval, TF-IDF, presentation builder и pretrained captioning wrapper.</a:t>
+              <a:t>Test loss: 2.7643.</a:t>
             </a:r>
           </a:p>
           <a:p>
             <a:pPr>
-              <a:defRPr sz="2400"/>
+              <a:spcAft>
+                <a:spcPts val="1000"/>
+              </a:spcAft>
+              <a:defRPr sz="2100">
+                <a:latin typeface="Calibri"/>
+              </a:defRPr>
             </a:pPr>
             <a:r>
-              <a:t>Последна проверка: `31 passed`.</a:t>
+              <a:t>BLEU-1: 0.5386.</a:t>
+            </a:r>
+          </a:p>
+          <a:p>
+            <a:pPr>
+              <a:spcAft>
+                <a:spcPts val="1000"/>
+              </a:spcAft>
+              <a:defRPr sz="2100">
+                <a:latin typeface="Calibri"/>
+              </a:defRPr>
+            </a:pPr>
+            <a:r>
+              <a:t>BLEU-4: 0.1392.</a:t>
+            </a:r>
+          </a:p>
+          <a:p>
+            <a:pPr>
+              <a:spcAft>
+                <a:spcPts val="1000"/>
+              </a:spcAft>
+              <a:defRPr sz="2100">
+                <a:latin typeface="Calibri"/>
+              </a:defRPr>
+            </a:pPr>
+            <a:r>
+              <a:t>ROUGE-L: 0.3918.</a:t>
+            </a:r>
+          </a:p>
+          <a:p>
+            <a:pPr>
+              <a:spcAft>
+                <a:spcPts val="1000"/>
+              </a:spcAft>
+              <a:defRPr sz="2100">
+                <a:latin typeface="Calibri"/>
+              </a:defRPr>
+            </a:pPr>
+            <a:r>
+              <a:t>Резултатите показват работещ baseline, но не и модел, който винаги описва точно произволни изображения.</a:t>
+            </a:r>
+          </a:p>
+        </p:txBody>
+      </p:sp>
+      <p:sp>
+        <p:nvSpPr>
+          <p:cNvPr id="5" name="TextBox 4"/>
+          <p:cNvSpPr txBox="1"/>
+          <p:nvPr/>
+        </p:nvSpPr>
+        <p:spPr>
+          <a:xfrm>
+            <a:off x="548640" y="6473952"/>
+            <a:ext cx="5486400" cy="228600"/>
+          </a:xfrm>
+          <a:prstGeom prst="rect">
+            <a:avLst/>
+          </a:prstGeom>
+          <a:noFill/>
+        </p:spPr>
+        <p:txBody>
+          <a:bodyPr wrap="none">
+            <a:spAutoFit/>
+          </a:bodyPr>
+          <a:lstStyle/>
+          <a:p>
+            <a:pPr algn="l"/>
+            <a:r>
+              <a:rPr sz="800" b="0" i="1">
+                <a:latin typeface="Calibri"/>
+              </a:rPr>
+              <a:t>Генериране на описание за изображение</a:t>
+            </a:r>
+          </a:p>
+        </p:txBody>
+      </p:sp>
+      <p:sp>
+        <p:nvSpPr>
+          <p:cNvPr id="6" name="TextBox 5"/>
+          <p:cNvSpPr txBox="1"/>
+          <p:nvPr/>
+        </p:nvSpPr>
+        <p:spPr>
+          <a:xfrm>
+            <a:off x="10972800" y="6473952"/>
+            <a:ext cx="640080" cy="228600"/>
+          </a:xfrm>
+          <a:prstGeom prst="rect">
+            <a:avLst/>
+          </a:prstGeom>
+          <a:noFill/>
+        </p:spPr>
+        <p:txBody>
+          <a:bodyPr wrap="none">
+            <a:spAutoFit/>
+          </a:bodyPr>
+          <a:lstStyle/>
+          <a:p>
+            <a:pPr algn="r"/>
+            <a:r>
+              <a:rPr sz="800" b="0" i="0">
+                <a:latin typeface="Calibri"/>
+              </a:rPr>
+              <a:t>11/15</a:t>
             </a:r>
           </a:p>
         </p:txBody>
@@ -3336,85 +3872,216 @@
       <p:grpSpPr/>
       <p:sp>
         <p:nvSpPr>
-          <p:cNvPr id="2" name="Title 1"/>
-          <p:cNvSpPr>
-            <a:spLocks noGrp="1"/>
-          </p:cNvSpPr>
-          <p:nvPr>
-            <p:ph type="title"/>
-          </p:nvPr>
-        </p:nvSpPr>
-        <p:spPr/>
-        <p:txBody>
-          <a:bodyPr/>
-          <a:lstStyle/>
-          <a:p>
-            <a:r>
-              <a:t>Слайд 12: Ограничения</a:t>
-            </a:r>
-          </a:p>
-        </p:txBody>
-      </p:sp>
-      <p:sp>
-        <p:nvSpPr>
-          <p:cNvPr id="3" name="Content Placeholder 2"/>
-          <p:cNvSpPr>
-            <a:spLocks noGrp="1"/>
-          </p:cNvSpPr>
-          <p:nvPr>
-            <p:ph idx="1"/>
-          </p:nvPr>
-        </p:nvSpPr>
-        <p:spPr/>
-        <p:txBody>
-          <a:bodyPr/>
+          <p:cNvPr id="2" name="TextBox 1"/>
+          <p:cNvSpPr txBox="1"/>
+          <p:nvPr/>
+        </p:nvSpPr>
+        <p:spPr>
+          <a:xfrm>
+            <a:off x="640080" y="411480"/>
+            <a:ext cx="10972800" cy="502920"/>
+          </a:xfrm>
+          <a:prstGeom prst="rect">
+            <a:avLst/>
+          </a:prstGeom>
+          <a:noFill/>
+        </p:spPr>
+        <p:txBody>
+          <a:bodyPr wrap="none">
+            <a:spAutoFit/>
+          </a:bodyPr>
+          <a:lstStyle/>
+          <a:p>
+            <a:pPr algn="l"/>
+            <a:r>
+              <a:rPr sz="2600" b="1" i="0">
+                <a:latin typeface="Calibri"/>
+              </a:rPr>
+              <a:t>Потребителски интерфейс</a:t>
+            </a:r>
+          </a:p>
+        </p:txBody>
+      </p:sp>
+      <p:sp>
+        <p:nvSpPr>
+          <p:cNvPr id="3" name="Rectangle 2"/>
+          <p:cNvSpPr/>
+          <p:nvPr/>
+        </p:nvSpPr>
+        <p:spPr>
+          <a:xfrm>
+            <a:off x="640080" y="1005840"/>
+            <a:ext cx="10881360" cy="9144"/>
+          </a:xfrm>
+          <a:prstGeom prst="rect">
+            <a:avLst/>
+          </a:prstGeom>
+          <a:solidFill>
+            <a:srgbClr val="000000"/>
+          </a:solidFill>
+          <a:ln>
+            <a:solidFill>
+              <a:srgbClr val="000000"/>
+            </a:solidFill>
+          </a:ln>
+        </p:spPr>
+        <p:style>
+          <a:lnRef idx="1">
+            <a:schemeClr val="accent1"/>
+          </a:lnRef>
+          <a:fillRef idx="3">
+            <a:schemeClr val="accent1"/>
+          </a:fillRef>
+          <a:effectRef idx="2">
+            <a:schemeClr val="accent1"/>
+          </a:effectRef>
+          <a:fontRef idx="minor">
+            <a:schemeClr val="lt1"/>
+          </a:fontRef>
+        </p:style>
+        <p:txBody>
+          <a:bodyPr rtlCol="0" anchor="ctr"/>
+          <a:lstStyle/>
+          <a:p>
+            <a:pPr algn="ctr"/>
+          </a:p>
+        </p:txBody>
+      </p:sp>
+      <p:sp>
+        <p:nvSpPr>
+          <p:cNvPr id="4" name="TextBox 3"/>
+          <p:cNvSpPr txBox="1"/>
+          <p:nvPr/>
+        </p:nvSpPr>
+        <p:spPr>
+          <a:xfrm>
+            <a:off x="868680" y="1325880"/>
+            <a:ext cx="10424160" cy="4754880"/>
+          </a:xfrm>
+          <a:prstGeom prst="rect">
+            <a:avLst/>
+          </a:prstGeom>
+          <a:noFill/>
+        </p:spPr>
+        <p:txBody>
+          <a:bodyPr wrap="square">
+            <a:spAutoFit/>
+          </a:bodyPr>
           <a:lstStyle/>
           <a:p>
             <a:pPr>
-              <a:defRPr sz="2400"/>
+              <a:spcAft>
+                <a:spcPts val="1000"/>
+              </a:spcAft>
+              <a:defRPr sz="2100">
+                <a:latin typeface="Calibri"/>
+              </a:defRPr>
             </a:pPr>
             <a:r>
-              <a:t>Flickr8k е малък dataset и не покрива всички ежедневни сцени.</a:t>
+              <a:t>Изградено е Streamlit приложение за качване на изображение и генериране на описание.</a:t>
             </a:r>
           </a:p>
           <a:p>
             <a:pPr>
-              <a:defRPr sz="2400"/>
+              <a:spcAft>
+                <a:spcPts val="1000"/>
+              </a:spcAft>
+              <a:defRPr sz="2100">
+                <a:latin typeface="Calibri"/>
+              </a:defRPr>
             </a:pPr>
             <a:r>
-              <a:t>VGG16 + LSTM е baseline модел без attention.</a:t>
+              <a:t>Интерфейсът показва входното изображение, генерирания текст и информация за използвания режим.</a:t>
             </a:r>
           </a:p>
           <a:p>
             <a:pPr>
-              <a:defRPr sz="2400"/>
+              <a:spcAft>
+                <a:spcPts val="1000"/>
+              </a:spcAft>
+              <a:defRPr sz="2100">
+                <a:latin typeface="Calibri"/>
+              </a:defRPr>
             </a:pPr>
             <a:r>
-              <a:t>При произволни снимки captions могат да бъдат generic или неточни.</a:t>
+              <a:t>Налични са три режима: VGG retrieval, VGG16 + LSTM и BLIP.</a:t>
             </a:r>
           </a:p>
           <a:p>
             <a:pPr>
-              <a:defRPr sz="2400"/>
+              <a:spcAft>
+                <a:spcPts val="1000"/>
+              </a:spcAft>
+              <a:defRPr sz="2100">
+                <a:latin typeface="Calibri"/>
+              </a:defRPr>
             </a:pPr>
             <a:r>
-              <a:t>Beam search подобрява decoding-а, но не решава напълно ограниченията на модела.</a:t>
-            </a:r>
-          </a:p>
-          <a:p>
-            <a:pPr>
-              <a:defRPr sz="2400"/>
-            </a:pPr>
-            <a:r>
-              <a:t>VGG retrieval намалява несвързаните captions чрез визуално подобни train примери.</a:t>
-            </a:r>
-          </a:p>
-          <a:p>
-            <a:pPr>
-              <a:defRPr sz="2400"/>
-            </a:pPr>
-            <a:r>
-              <a:t>Pretrained BLIP режимът служи като сравнение с по-силен модел.</a:t>
+              <a:t>Това позволява да се сравни собствената реализация с по-силен предварително обучен модел.</a:t>
+            </a:r>
+          </a:p>
+        </p:txBody>
+      </p:sp>
+      <p:sp>
+        <p:nvSpPr>
+          <p:cNvPr id="5" name="TextBox 4"/>
+          <p:cNvSpPr txBox="1"/>
+          <p:nvPr/>
+        </p:nvSpPr>
+        <p:spPr>
+          <a:xfrm>
+            <a:off x="548640" y="6473952"/>
+            <a:ext cx="5486400" cy="228600"/>
+          </a:xfrm>
+          <a:prstGeom prst="rect">
+            <a:avLst/>
+          </a:prstGeom>
+          <a:noFill/>
+        </p:spPr>
+        <p:txBody>
+          <a:bodyPr wrap="none">
+            <a:spAutoFit/>
+          </a:bodyPr>
+          <a:lstStyle/>
+          <a:p>
+            <a:pPr algn="l"/>
+            <a:r>
+              <a:rPr sz="800" b="0" i="1">
+                <a:latin typeface="Calibri"/>
+              </a:rPr>
+              <a:t>Генериране на описание за изображение</a:t>
+            </a:r>
+          </a:p>
+        </p:txBody>
+      </p:sp>
+      <p:sp>
+        <p:nvSpPr>
+          <p:cNvPr id="6" name="TextBox 5"/>
+          <p:cNvSpPr txBox="1"/>
+          <p:nvPr/>
+        </p:nvSpPr>
+        <p:spPr>
+          <a:xfrm>
+            <a:off x="10972800" y="6473952"/>
+            <a:ext cx="640080" cy="228600"/>
+          </a:xfrm>
+          <a:prstGeom prst="rect">
+            <a:avLst/>
+          </a:prstGeom>
+          <a:noFill/>
+        </p:spPr>
+        <p:txBody>
+          <a:bodyPr wrap="none">
+            <a:spAutoFit/>
+          </a:bodyPr>
+          <a:lstStyle/>
+          <a:p>
+            <a:pPr algn="r"/>
+            <a:r>
+              <a:rPr sz="800" b="0" i="0">
+                <a:latin typeface="Calibri"/>
+              </a:rPr>
+              <a:t>12/15</a:t>
             </a:r>
           </a:p>
         </p:txBody>
@@ -3439,69 +4106,684 @@
       <p:grpSpPr/>
       <p:sp>
         <p:nvSpPr>
-          <p:cNvPr id="2" name="Title 1"/>
-          <p:cNvSpPr>
-            <a:spLocks noGrp="1"/>
-          </p:cNvSpPr>
-          <p:nvPr>
-            <p:ph type="title"/>
-          </p:nvPr>
-        </p:nvSpPr>
-        <p:spPr/>
-        <p:txBody>
-          <a:bodyPr/>
-          <a:lstStyle/>
-          <a:p>
-            <a:r>
-              <a:t>Слайд 13: Изводи и бъдещи подобрения</a:t>
-            </a:r>
-          </a:p>
-        </p:txBody>
-      </p:sp>
-      <p:sp>
-        <p:nvSpPr>
-          <p:cNvPr id="3" name="Content Placeholder 2"/>
-          <p:cNvSpPr>
-            <a:spLocks noGrp="1"/>
-          </p:cNvSpPr>
-          <p:nvPr>
-            <p:ph idx="1"/>
-          </p:nvPr>
-        </p:nvSpPr>
-        <p:spPr/>
-        <p:txBody>
-          <a:bodyPr/>
+          <p:cNvPr id="2" name="TextBox 1"/>
+          <p:cNvSpPr txBox="1"/>
+          <p:nvPr/>
+        </p:nvSpPr>
+        <p:spPr>
+          <a:xfrm>
+            <a:off x="640080" y="411480"/>
+            <a:ext cx="10972800" cy="502920"/>
+          </a:xfrm>
+          <a:prstGeom prst="rect">
+            <a:avLst/>
+          </a:prstGeom>
+          <a:noFill/>
+        </p:spPr>
+        <p:txBody>
+          <a:bodyPr wrap="none">
+            <a:spAutoFit/>
+          </a:bodyPr>
+          <a:lstStyle/>
+          <a:p>
+            <a:pPr algn="l"/>
+            <a:r>
+              <a:rPr sz="2600" b="1" i="0">
+                <a:latin typeface="Calibri"/>
+              </a:rPr>
+              <a:t>Тестове</a:t>
+            </a:r>
+          </a:p>
+        </p:txBody>
+      </p:sp>
+      <p:sp>
+        <p:nvSpPr>
+          <p:cNvPr id="3" name="Rectangle 2"/>
+          <p:cNvSpPr/>
+          <p:nvPr/>
+        </p:nvSpPr>
+        <p:spPr>
+          <a:xfrm>
+            <a:off x="640080" y="1005840"/>
+            <a:ext cx="10881360" cy="9144"/>
+          </a:xfrm>
+          <a:prstGeom prst="rect">
+            <a:avLst/>
+          </a:prstGeom>
+          <a:solidFill>
+            <a:srgbClr val="000000"/>
+          </a:solidFill>
+          <a:ln>
+            <a:solidFill>
+              <a:srgbClr val="000000"/>
+            </a:solidFill>
+          </a:ln>
+        </p:spPr>
+        <p:style>
+          <a:lnRef idx="1">
+            <a:schemeClr val="accent1"/>
+          </a:lnRef>
+          <a:fillRef idx="3">
+            <a:schemeClr val="accent1"/>
+          </a:fillRef>
+          <a:effectRef idx="2">
+            <a:schemeClr val="accent1"/>
+          </a:effectRef>
+          <a:fontRef idx="minor">
+            <a:schemeClr val="lt1"/>
+          </a:fontRef>
+        </p:style>
+        <p:txBody>
+          <a:bodyPr rtlCol="0" anchor="ctr"/>
+          <a:lstStyle/>
+          <a:p>
+            <a:pPr algn="ctr"/>
+          </a:p>
+        </p:txBody>
+      </p:sp>
+      <p:sp>
+        <p:nvSpPr>
+          <p:cNvPr id="4" name="TextBox 3"/>
+          <p:cNvSpPr txBox="1"/>
+          <p:nvPr/>
+        </p:nvSpPr>
+        <p:spPr>
+          <a:xfrm>
+            <a:off x="868680" y="1325880"/>
+            <a:ext cx="10424160" cy="4754880"/>
+          </a:xfrm>
+          <a:prstGeom prst="rect">
+            <a:avLst/>
+          </a:prstGeom>
+          <a:noFill/>
+        </p:spPr>
+        <p:txBody>
+          <a:bodyPr wrap="square">
+            <a:spAutoFit/>
+          </a:bodyPr>
           <a:lstStyle/>
           <a:p>
             <a:pPr>
-              <a:defRPr sz="2400"/>
+              <a:spcAft>
+                <a:spcPts val="1000"/>
+              </a:spcAft>
+              <a:defRPr sz="2100">
+                <a:latin typeface="Calibri"/>
+              </a:defRPr>
             </a:pPr>
             <a:r>
-              <a:t>VGG16 + LSTM дава работещ baseline.</a:t>
+              <a:t>Написани са тестове за речника, зареждането на данните и split логиката.</a:t>
             </a:r>
           </a:p>
           <a:p>
             <a:pPr>
-              <a:defRPr sz="2400"/>
+              <a:spcAft>
+                <a:spcPts val="1000"/>
+              </a:spcAft>
+              <a:defRPr sz="2100">
+                <a:latin typeface="Calibri"/>
+              </a:defRPr>
             </a:pPr>
             <a:r>
-              <a:t>Attention или transformer модел вероятно би подобрил качеството.</a:t>
+              <a:t>Проверени са модулите за модел, обучение, оценка и inference.</a:t>
             </a:r>
           </a:p>
           <a:p>
             <a:pPr>
-              <a:defRPr sz="2400"/>
+              <a:spcAft>
+                <a:spcPts val="1000"/>
+              </a:spcAft>
+              <a:defRPr sz="2100">
+                <a:latin typeface="Calibri"/>
+              </a:defRPr>
             </a:pPr>
             <a:r>
-              <a:t>Beam search може да подобри inference-а.</a:t>
+              <a:t>Има тестове за retrieval baseline, TF-IDF експериментите и генерирането на презентацията.</a:t>
             </a:r>
           </a:p>
           <a:p>
             <a:pPr>
-              <a:defRPr sz="2400"/>
+              <a:spcAft>
+                <a:spcPts val="1000"/>
+              </a:spcAft>
+              <a:defRPr sz="2100">
+                <a:latin typeface="Calibri"/>
+              </a:defRPr>
             </a:pPr>
             <a:r>
-              <a:t>Могат да се добавят повече architecture и embedding експерименти.</a:t>
+              <a:t>Последната пълна проверка на проекта преминава с 31 успешни теста.</a:t>
+            </a:r>
+          </a:p>
+        </p:txBody>
+      </p:sp>
+      <p:sp>
+        <p:nvSpPr>
+          <p:cNvPr id="5" name="TextBox 4"/>
+          <p:cNvSpPr txBox="1"/>
+          <p:nvPr/>
+        </p:nvSpPr>
+        <p:spPr>
+          <a:xfrm>
+            <a:off x="548640" y="6473952"/>
+            <a:ext cx="5486400" cy="228600"/>
+          </a:xfrm>
+          <a:prstGeom prst="rect">
+            <a:avLst/>
+          </a:prstGeom>
+          <a:noFill/>
+        </p:spPr>
+        <p:txBody>
+          <a:bodyPr wrap="none">
+            <a:spAutoFit/>
+          </a:bodyPr>
+          <a:lstStyle/>
+          <a:p>
+            <a:pPr algn="l"/>
+            <a:r>
+              <a:rPr sz="800" b="0" i="1">
+                <a:latin typeface="Calibri"/>
+              </a:rPr>
+              <a:t>Генериране на описание за изображение</a:t>
+            </a:r>
+          </a:p>
+        </p:txBody>
+      </p:sp>
+      <p:sp>
+        <p:nvSpPr>
+          <p:cNvPr id="6" name="TextBox 5"/>
+          <p:cNvSpPr txBox="1"/>
+          <p:nvPr/>
+        </p:nvSpPr>
+        <p:spPr>
+          <a:xfrm>
+            <a:off x="10972800" y="6473952"/>
+            <a:ext cx="640080" cy="228600"/>
+          </a:xfrm>
+          <a:prstGeom prst="rect">
+            <a:avLst/>
+          </a:prstGeom>
+          <a:noFill/>
+        </p:spPr>
+        <p:txBody>
+          <a:bodyPr wrap="none">
+            <a:spAutoFit/>
+          </a:bodyPr>
+          <a:lstStyle/>
+          <a:p>
+            <a:pPr algn="r"/>
+            <a:r>
+              <a:rPr sz="800" b="0" i="0">
+                <a:latin typeface="Calibri"/>
+              </a:rPr>
+              <a:t>13/15</a:t>
+            </a:r>
+          </a:p>
+        </p:txBody>
+      </p:sp>
+    </p:spTree>
+  </p:cSld>
+  <p:clrMapOvr>
+    <a:masterClrMapping/>
+  </p:clrMapOvr>
+</p:sld>
+</file>
+
+<file path=ppt/slides/slide14.xml><?xml version="1.0" encoding="utf-8"?>
+<p:sld xmlns:a="http://schemas.openxmlformats.org/drawingml/2006/main" xmlns:p="http://schemas.openxmlformats.org/presentationml/2006/main" xmlns:r="http://schemas.openxmlformats.org/officeDocument/2006/relationships">
+  <p:cSld>
+    <p:spTree>
+      <p:nvGrpSpPr>
+        <p:cNvPr id="1" name=""/>
+        <p:cNvGrpSpPr/>
+        <p:nvPr/>
+      </p:nvGrpSpPr>
+      <p:grpSpPr/>
+      <p:sp>
+        <p:nvSpPr>
+          <p:cNvPr id="2" name="TextBox 1"/>
+          <p:cNvSpPr txBox="1"/>
+          <p:nvPr/>
+        </p:nvSpPr>
+        <p:spPr>
+          <a:xfrm>
+            <a:off x="640080" y="411480"/>
+            <a:ext cx="10972800" cy="502920"/>
+          </a:xfrm>
+          <a:prstGeom prst="rect">
+            <a:avLst/>
+          </a:prstGeom>
+          <a:noFill/>
+        </p:spPr>
+        <p:txBody>
+          <a:bodyPr wrap="none">
+            <a:spAutoFit/>
+          </a:bodyPr>
+          <a:lstStyle/>
+          <a:p>
+            <a:pPr algn="l"/>
+            <a:r>
+              <a:rPr sz="2600" b="1" i="0">
+                <a:latin typeface="Calibri"/>
+              </a:rPr>
+              <a:t>Ограничения</a:t>
+            </a:r>
+          </a:p>
+        </p:txBody>
+      </p:sp>
+      <p:sp>
+        <p:nvSpPr>
+          <p:cNvPr id="3" name="Rectangle 2"/>
+          <p:cNvSpPr/>
+          <p:nvPr/>
+        </p:nvSpPr>
+        <p:spPr>
+          <a:xfrm>
+            <a:off x="640080" y="1005840"/>
+            <a:ext cx="10881360" cy="9144"/>
+          </a:xfrm>
+          <a:prstGeom prst="rect">
+            <a:avLst/>
+          </a:prstGeom>
+          <a:solidFill>
+            <a:srgbClr val="000000"/>
+          </a:solidFill>
+          <a:ln>
+            <a:solidFill>
+              <a:srgbClr val="000000"/>
+            </a:solidFill>
+          </a:ln>
+        </p:spPr>
+        <p:style>
+          <a:lnRef idx="1">
+            <a:schemeClr val="accent1"/>
+          </a:lnRef>
+          <a:fillRef idx="3">
+            <a:schemeClr val="accent1"/>
+          </a:fillRef>
+          <a:effectRef idx="2">
+            <a:schemeClr val="accent1"/>
+          </a:effectRef>
+          <a:fontRef idx="minor">
+            <a:schemeClr val="lt1"/>
+          </a:fontRef>
+        </p:style>
+        <p:txBody>
+          <a:bodyPr rtlCol="0" anchor="ctr"/>
+          <a:lstStyle/>
+          <a:p>
+            <a:pPr algn="ctr"/>
+          </a:p>
+        </p:txBody>
+      </p:sp>
+      <p:sp>
+        <p:nvSpPr>
+          <p:cNvPr id="4" name="TextBox 3"/>
+          <p:cNvSpPr txBox="1"/>
+          <p:nvPr/>
+        </p:nvSpPr>
+        <p:spPr>
+          <a:xfrm>
+            <a:off x="868680" y="1325880"/>
+            <a:ext cx="10424160" cy="4754880"/>
+          </a:xfrm>
+          <a:prstGeom prst="rect">
+            <a:avLst/>
+          </a:prstGeom>
+          <a:noFill/>
+        </p:spPr>
+        <p:txBody>
+          <a:bodyPr wrap="square">
+            <a:spAutoFit/>
+          </a:bodyPr>
+          <a:lstStyle/>
+          <a:p>
+            <a:pPr>
+              <a:spcAft>
+                <a:spcPts val="1000"/>
+              </a:spcAft>
+              <a:defRPr sz="2100">
+                <a:latin typeface="Calibri"/>
+              </a:defRPr>
+            </a:pPr>
+            <a:r>
+              <a:t>Flickr8k е сравнително малък набор от данни и не покрива всички ситуации от реалния свят.</a:t>
+            </a:r>
+          </a:p>
+          <a:p>
+            <a:pPr>
+              <a:spcAft>
+                <a:spcPts val="1000"/>
+              </a:spcAft>
+              <a:defRPr sz="2100">
+                <a:latin typeface="Calibri"/>
+              </a:defRPr>
+            </a:pPr>
+            <a:r>
+              <a:t>VGG16 + LSTM без attention често генерира общи или неточни описания.</a:t>
+            </a:r>
+          </a:p>
+          <a:p>
+            <a:pPr>
+              <a:spcAft>
+                <a:spcPts val="1000"/>
+              </a:spcAft>
+              <a:defRPr sz="2100">
+                <a:latin typeface="Calibri"/>
+              </a:defRPr>
+            </a:pPr>
+            <a:r>
+              <a:t>Качеството е по-добро при изображения, подобни на тези в training частта.</a:t>
+            </a:r>
+          </a:p>
+          <a:p>
+            <a:pPr>
+              <a:spcAft>
+                <a:spcPts val="1000"/>
+              </a:spcAft>
+              <a:defRPr sz="2100">
+                <a:latin typeface="Calibri"/>
+              </a:defRPr>
+            </a:pPr>
+            <a:r>
+              <a:t>Retrieval режимът е по-стабилен за демонстрация, но не създава напълно нов текст.</a:t>
+            </a:r>
+          </a:p>
+        </p:txBody>
+      </p:sp>
+      <p:sp>
+        <p:nvSpPr>
+          <p:cNvPr id="5" name="TextBox 4"/>
+          <p:cNvSpPr txBox="1"/>
+          <p:nvPr/>
+        </p:nvSpPr>
+        <p:spPr>
+          <a:xfrm>
+            <a:off x="548640" y="6473952"/>
+            <a:ext cx="5486400" cy="228600"/>
+          </a:xfrm>
+          <a:prstGeom prst="rect">
+            <a:avLst/>
+          </a:prstGeom>
+          <a:noFill/>
+        </p:spPr>
+        <p:txBody>
+          <a:bodyPr wrap="none">
+            <a:spAutoFit/>
+          </a:bodyPr>
+          <a:lstStyle/>
+          <a:p>
+            <a:pPr algn="l"/>
+            <a:r>
+              <a:rPr sz="800" b="0" i="1">
+                <a:latin typeface="Calibri"/>
+              </a:rPr>
+              <a:t>Генериране на описание за изображение</a:t>
+            </a:r>
+          </a:p>
+        </p:txBody>
+      </p:sp>
+      <p:sp>
+        <p:nvSpPr>
+          <p:cNvPr id="6" name="TextBox 5"/>
+          <p:cNvSpPr txBox="1"/>
+          <p:nvPr/>
+        </p:nvSpPr>
+        <p:spPr>
+          <a:xfrm>
+            <a:off x="10972800" y="6473952"/>
+            <a:ext cx="640080" cy="228600"/>
+          </a:xfrm>
+          <a:prstGeom prst="rect">
+            <a:avLst/>
+          </a:prstGeom>
+          <a:noFill/>
+        </p:spPr>
+        <p:txBody>
+          <a:bodyPr wrap="none">
+            <a:spAutoFit/>
+          </a:bodyPr>
+          <a:lstStyle/>
+          <a:p>
+            <a:pPr algn="r"/>
+            <a:r>
+              <a:rPr sz="800" b="0" i="0">
+                <a:latin typeface="Calibri"/>
+              </a:rPr>
+              <a:t>14/15</a:t>
+            </a:r>
+          </a:p>
+        </p:txBody>
+      </p:sp>
+    </p:spTree>
+  </p:cSld>
+  <p:clrMapOvr>
+    <a:masterClrMapping/>
+  </p:clrMapOvr>
+</p:sld>
+</file>
+
+<file path=ppt/slides/slide15.xml><?xml version="1.0" encoding="utf-8"?>
+<p:sld xmlns:a="http://schemas.openxmlformats.org/drawingml/2006/main" xmlns:p="http://schemas.openxmlformats.org/presentationml/2006/main" xmlns:r="http://schemas.openxmlformats.org/officeDocument/2006/relationships">
+  <p:cSld>
+    <p:spTree>
+      <p:nvGrpSpPr>
+        <p:cNvPr id="1" name=""/>
+        <p:cNvGrpSpPr/>
+        <p:nvPr/>
+      </p:nvGrpSpPr>
+      <p:grpSpPr/>
+      <p:sp>
+        <p:nvSpPr>
+          <p:cNvPr id="2" name="TextBox 1"/>
+          <p:cNvSpPr txBox="1"/>
+          <p:nvPr/>
+        </p:nvSpPr>
+        <p:spPr>
+          <a:xfrm>
+            <a:off x="640080" y="411480"/>
+            <a:ext cx="10972800" cy="502920"/>
+          </a:xfrm>
+          <a:prstGeom prst="rect">
+            <a:avLst/>
+          </a:prstGeom>
+          <a:noFill/>
+        </p:spPr>
+        <p:txBody>
+          <a:bodyPr wrap="none">
+            <a:spAutoFit/>
+          </a:bodyPr>
+          <a:lstStyle/>
+          <a:p>
+            <a:pPr algn="l"/>
+            <a:r>
+              <a:rPr sz="2600" b="1" i="0">
+                <a:latin typeface="Calibri"/>
+              </a:rPr>
+              <a:t>Изводи и бъдещо развитие</a:t>
+            </a:r>
+          </a:p>
+        </p:txBody>
+      </p:sp>
+      <p:sp>
+        <p:nvSpPr>
+          <p:cNvPr id="3" name="Rectangle 2"/>
+          <p:cNvSpPr/>
+          <p:nvPr/>
+        </p:nvSpPr>
+        <p:spPr>
+          <a:xfrm>
+            <a:off x="640080" y="1005840"/>
+            <a:ext cx="10881360" cy="9144"/>
+          </a:xfrm>
+          <a:prstGeom prst="rect">
+            <a:avLst/>
+          </a:prstGeom>
+          <a:solidFill>
+            <a:srgbClr val="000000"/>
+          </a:solidFill>
+          <a:ln>
+            <a:solidFill>
+              <a:srgbClr val="000000"/>
+            </a:solidFill>
+          </a:ln>
+        </p:spPr>
+        <p:style>
+          <a:lnRef idx="1">
+            <a:schemeClr val="accent1"/>
+          </a:lnRef>
+          <a:fillRef idx="3">
+            <a:schemeClr val="accent1"/>
+          </a:fillRef>
+          <a:effectRef idx="2">
+            <a:schemeClr val="accent1"/>
+          </a:effectRef>
+          <a:fontRef idx="minor">
+            <a:schemeClr val="lt1"/>
+          </a:fontRef>
+        </p:style>
+        <p:txBody>
+          <a:bodyPr rtlCol="0" anchor="ctr"/>
+          <a:lstStyle/>
+          <a:p>
+            <a:pPr algn="ctr"/>
+          </a:p>
+        </p:txBody>
+      </p:sp>
+      <p:sp>
+        <p:nvSpPr>
+          <p:cNvPr id="4" name="TextBox 3"/>
+          <p:cNvSpPr txBox="1"/>
+          <p:nvPr/>
+        </p:nvSpPr>
+        <p:spPr>
+          <a:xfrm>
+            <a:off x="868680" y="1325880"/>
+            <a:ext cx="10424160" cy="4754880"/>
+          </a:xfrm>
+          <a:prstGeom prst="rect">
+            <a:avLst/>
+          </a:prstGeom>
+          <a:noFill/>
+        </p:spPr>
+        <p:txBody>
+          <a:bodyPr wrap="square">
+            <a:spAutoFit/>
+          </a:bodyPr>
+          <a:lstStyle/>
+          <a:p>
+            <a:pPr>
+              <a:spcAft>
+                <a:spcPts val="1000"/>
+              </a:spcAft>
+              <a:defRPr sz="2100">
+                <a:latin typeface="Calibri"/>
+              </a:defRPr>
+            </a:pPr>
+            <a:r>
+              <a:t>Проектът реализира пълен процес: данни, EDA, preprocessing, модел, оценка, тестове и уеб приложение.</a:t>
+            </a:r>
+          </a:p>
+          <a:p>
+            <a:pPr>
+              <a:spcAft>
+                <a:spcPts val="1000"/>
+              </a:spcAft>
+              <a:defRPr sz="2100">
+                <a:latin typeface="Calibri"/>
+              </a:defRPr>
+            </a:pPr>
+            <a:r>
+              <a:t>Основният модел показва как работи image captioning архитектура от тип CNN + LSTM.</a:t>
+            </a:r>
+          </a:p>
+          <a:p>
+            <a:pPr>
+              <a:spcAft>
+                <a:spcPts val="1000"/>
+              </a:spcAft>
+              <a:defRPr sz="2100">
+                <a:latin typeface="Calibri"/>
+              </a:defRPr>
+            </a:pPr>
+            <a:r>
+              <a:t>За по-високо качество следваща стъпка би била attention или transformer-базиран модел.</a:t>
+            </a:r>
+          </a:p>
+          <a:p>
+            <a:pPr>
+              <a:spcAft>
+                <a:spcPts val="1000"/>
+              </a:spcAft>
+              <a:defRPr sz="2100">
+                <a:latin typeface="Calibri"/>
+              </a:defRPr>
+            </a:pPr>
+            <a:r>
+              <a:t>Могат да се добавят повече данни, по-дълго обучение и по-подробна ръчна оценка на генерираните описания.</a:t>
+            </a:r>
+          </a:p>
+        </p:txBody>
+      </p:sp>
+      <p:sp>
+        <p:nvSpPr>
+          <p:cNvPr id="5" name="TextBox 4"/>
+          <p:cNvSpPr txBox="1"/>
+          <p:nvPr/>
+        </p:nvSpPr>
+        <p:spPr>
+          <a:xfrm>
+            <a:off x="548640" y="6473952"/>
+            <a:ext cx="5486400" cy="228600"/>
+          </a:xfrm>
+          <a:prstGeom prst="rect">
+            <a:avLst/>
+          </a:prstGeom>
+          <a:noFill/>
+        </p:spPr>
+        <p:txBody>
+          <a:bodyPr wrap="none">
+            <a:spAutoFit/>
+          </a:bodyPr>
+          <a:lstStyle/>
+          <a:p>
+            <a:pPr algn="l"/>
+            <a:r>
+              <a:rPr sz="800" b="0" i="1">
+                <a:latin typeface="Calibri"/>
+              </a:rPr>
+              <a:t>Генериране на описание за изображение</a:t>
+            </a:r>
+          </a:p>
+        </p:txBody>
+      </p:sp>
+      <p:sp>
+        <p:nvSpPr>
+          <p:cNvPr id="6" name="TextBox 5"/>
+          <p:cNvSpPr txBox="1"/>
+          <p:nvPr/>
+        </p:nvSpPr>
+        <p:spPr>
+          <a:xfrm>
+            <a:off x="10972800" y="6473952"/>
+            <a:ext cx="640080" cy="228600"/>
+          </a:xfrm>
+          <a:prstGeom prst="rect">
+            <a:avLst/>
+          </a:prstGeom>
+          <a:noFill/>
+        </p:spPr>
+        <p:txBody>
+          <a:bodyPr wrap="none">
+            <a:spAutoFit/>
+          </a:bodyPr>
+          <a:lstStyle/>
+          <a:p>
+            <a:pPr algn="r"/>
+            <a:r>
+              <a:rPr sz="800" b="0" i="0">
+                <a:latin typeface="Calibri"/>
+              </a:rPr>
+              <a:t>15/15</a:t>
             </a:r>
           </a:p>
         </p:txBody>
@@ -3526,61 +4808,229 @@
       <p:grpSpPr/>
       <p:sp>
         <p:nvSpPr>
-          <p:cNvPr id="2" name="Title 1"/>
-          <p:cNvSpPr>
-            <a:spLocks noGrp="1"/>
-          </p:cNvSpPr>
-          <p:nvPr>
-            <p:ph type="title"/>
-          </p:nvPr>
-        </p:nvSpPr>
-        <p:spPr/>
-        <p:txBody>
-          <a:bodyPr/>
-          <a:lstStyle/>
-          <a:p>
-            <a:r>
-              <a:t>Слайд 2: Какво представлява задачата</a:t>
-            </a:r>
-          </a:p>
-        </p:txBody>
-      </p:sp>
-      <p:sp>
-        <p:nvSpPr>
-          <p:cNvPr id="3" name="Content Placeholder 2"/>
-          <p:cNvSpPr>
-            <a:spLocks noGrp="1"/>
-          </p:cNvSpPr>
-          <p:nvPr>
-            <p:ph idx="1"/>
-          </p:nvPr>
-        </p:nvSpPr>
-        <p:spPr/>
-        <p:txBody>
-          <a:bodyPr/>
+          <p:cNvPr id="2" name="TextBox 1"/>
+          <p:cNvSpPr txBox="1"/>
+          <p:nvPr/>
+        </p:nvSpPr>
+        <p:spPr>
+          <a:xfrm>
+            <a:off x="640080" y="411480"/>
+            <a:ext cx="10972800" cy="502920"/>
+          </a:xfrm>
+          <a:prstGeom prst="rect">
+            <a:avLst/>
+          </a:prstGeom>
+          <a:noFill/>
+        </p:spPr>
+        <p:txBody>
+          <a:bodyPr wrap="none">
+            <a:spAutoFit/>
+          </a:bodyPr>
+          <a:lstStyle/>
+          <a:p>
+            <a:pPr algn="l"/>
+            <a:r>
+              <a:rPr sz="2600" b="1" i="0">
+                <a:latin typeface="Calibri"/>
+              </a:rPr>
+              <a:t>Съдържание</a:t>
+            </a:r>
+          </a:p>
+        </p:txBody>
+      </p:sp>
+      <p:sp>
+        <p:nvSpPr>
+          <p:cNvPr id="3" name="Rectangle 2"/>
+          <p:cNvSpPr/>
+          <p:nvPr/>
+        </p:nvSpPr>
+        <p:spPr>
+          <a:xfrm>
+            <a:off x="640080" y="1005840"/>
+            <a:ext cx="10881360" cy="9144"/>
+          </a:xfrm>
+          <a:prstGeom prst="rect">
+            <a:avLst/>
+          </a:prstGeom>
+          <a:solidFill>
+            <a:srgbClr val="000000"/>
+          </a:solidFill>
+          <a:ln>
+            <a:solidFill>
+              <a:srgbClr val="000000"/>
+            </a:solidFill>
+          </a:ln>
+        </p:spPr>
+        <p:style>
+          <a:lnRef idx="1">
+            <a:schemeClr val="accent1"/>
+          </a:lnRef>
+          <a:fillRef idx="3">
+            <a:schemeClr val="accent1"/>
+          </a:fillRef>
+          <a:effectRef idx="2">
+            <a:schemeClr val="accent1"/>
+          </a:effectRef>
+          <a:fontRef idx="minor">
+            <a:schemeClr val="lt1"/>
+          </a:fontRef>
+        </p:style>
+        <p:txBody>
+          <a:bodyPr rtlCol="0" anchor="ctr"/>
+          <a:lstStyle/>
+          <a:p>
+            <a:pPr algn="ctr"/>
+          </a:p>
+        </p:txBody>
+      </p:sp>
+      <p:sp>
+        <p:nvSpPr>
+          <p:cNvPr id="4" name="TextBox 3"/>
+          <p:cNvSpPr txBox="1"/>
+          <p:nvPr/>
+        </p:nvSpPr>
+        <p:spPr>
+          <a:xfrm>
+            <a:off x="868680" y="1325880"/>
+            <a:ext cx="10424160" cy="4754880"/>
+          </a:xfrm>
+          <a:prstGeom prst="rect">
+            <a:avLst/>
+          </a:prstGeom>
+          <a:noFill/>
+        </p:spPr>
+        <p:txBody>
+          <a:bodyPr wrap="square">
+            <a:spAutoFit/>
+          </a:bodyPr>
           <a:lstStyle/>
           <a:p>
             <a:pPr>
-              <a:defRPr sz="2400"/>
+              <a:spcAft>
+                <a:spcPts val="1000"/>
+              </a:spcAft>
+              <a:defRPr sz="2100">
+                <a:latin typeface="Calibri"/>
+              </a:defRPr>
             </a:pPr>
             <a:r>
-              <a:t>Image captioning комбинира computer vision и NLP.</a:t>
+              <a:t>Цел на проекта и описание на задачата</a:t>
             </a:r>
           </a:p>
           <a:p>
             <a:pPr>
-              <a:defRPr sz="2400"/>
+              <a:spcAft>
+                <a:spcPts val="1000"/>
+              </a:spcAft>
+              <a:defRPr sz="2100">
+                <a:latin typeface="Calibri"/>
+              </a:defRPr>
             </a:pPr>
             <a:r>
-              <a:t>Моделът трябва да разпознае визуалното съдържание и да го превърне в текст.</a:t>
+              <a:t>Използван набор от данни</a:t>
             </a:r>
           </a:p>
           <a:p>
             <a:pPr>
-              <a:defRPr sz="2400"/>
+              <a:spcAft>
+                <a:spcPts val="1000"/>
+              </a:spcAft>
+              <a:defRPr sz="2100">
+                <a:latin typeface="Calibri"/>
+              </a:defRPr>
             </a:pPr>
             <a:r>
-              <a:t>Изходът е последователност от думи, не единичен class label.</a:t>
+              <a:t>Разглеждане и предварителна обработка на данните</a:t>
+            </a:r>
+          </a:p>
+          <a:p>
+            <a:pPr>
+              <a:spcAft>
+                <a:spcPts val="1000"/>
+              </a:spcAft>
+              <a:defRPr sz="2100">
+                <a:latin typeface="Calibri"/>
+              </a:defRPr>
+            </a:pPr>
+            <a:r>
+              <a:t>Модел, обучение и експерименти</a:t>
+            </a:r>
+          </a:p>
+          <a:p>
+            <a:pPr>
+              <a:spcAft>
+                <a:spcPts val="1000"/>
+              </a:spcAft>
+              <a:defRPr sz="2100">
+                <a:latin typeface="Calibri"/>
+              </a:defRPr>
+            </a:pPr>
+            <a:r>
+              <a:t>Потребителски интерфейс, резултати и изводи</a:t>
+            </a:r>
+          </a:p>
+        </p:txBody>
+      </p:sp>
+      <p:sp>
+        <p:nvSpPr>
+          <p:cNvPr id="5" name="TextBox 4"/>
+          <p:cNvSpPr txBox="1"/>
+          <p:nvPr/>
+        </p:nvSpPr>
+        <p:spPr>
+          <a:xfrm>
+            <a:off x="548640" y="6473952"/>
+            <a:ext cx="5486400" cy="228600"/>
+          </a:xfrm>
+          <a:prstGeom prst="rect">
+            <a:avLst/>
+          </a:prstGeom>
+          <a:noFill/>
+        </p:spPr>
+        <p:txBody>
+          <a:bodyPr wrap="none">
+            <a:spAutoFit/>
+          </a:bodyPr>
+          <a:lstStyle/>
+          <a:p>
+            <a:pPr algn="l"/>
+            <a:r>
+              <a:rPr sz="800" b="0" i="1">
+                <a:latin typeface="Calibri"/>
+              </a:rPr>
+              <a:t>Генериране на описание за изображение</a:t>
+            </a:r>
+          </a:p>
+        </p:txBody>
+      </p:sp>
+      <p:sp>
+        <p:nvSpPr>
+          <p:cNvPr id="6" name="TextBox 5"/>
+          <p:cNvSpPr txBox="1"/>
+          <p:nvPr/>
+        </p:nvSpPr>
+        <p:spPr>
+          <a:xfrm>
+            <a:off x="10972800" y="6473952"/>
+            <a:ext cx="640080" cy="228600"/>
+          </a:xfrm>
+          <a:prstGeom prst="rect">
+            <a:avLst/>
+          </a:prstGeom>
+          <a:noFill/>
+        </p:spPr>
+        <p:txBody>
+          <a:bodyPr wrap="none">
+            <a:spAutoFit/>
+          </a:bodyPr>
+          <a:lstStyle/>
+          <a:p>
+            <a:pPr algn="r"/>
+            <a:r>
+              <a:rPr sz="800" b="0" i="0">
+                <a:latin typeface="Calibri"/>
+              </a:rPr>
+              <a:t>2/15</a:t>
             </a:r>
           </a:p>
         </p:txBody>
@@ -3605,69 +5055,216 @@
       <p:grpSpPr/>
       <p:sp>
         <p:nvSpPr>
-          <p:cNvPr id="2" name="Title 1"/>
-          <p:cNvSpPr>
-            <a:spLocks noGrp="1"/>
-          </p:cNvSpPr>
-          <p:nvPr>
-            <p:ph type="title"/>
-          </p:nvPr>
-        </p:nvSpPr>
-        <p:spPr/>
-        <p:txBody>
-          <a:bodyPr/>
-          <a:lstStyle/>
-          <a:p>
-            <a:r>
-              <a:t>Слайд 3: Разгледани техники</a:t>
-            </a:r>
-          </a:p>
-        </p:txBody>
-      </p:sp>
-      <p:sp>
-        <p:nvSpPr>
-          <p:cNvPr id="3" name="Content Placeholder 2"/>
-          <p:cNvSpPr>
-            <a:spLocks noGrp="1"/>
-          </p:cNvSpPr>
-          <p:nvPr>
-            <p:ph idx="1"/>
-          </p:nvPr>
-        </p:nvSpPr>
-        <p:spPr/>
-        <p:txBody>
-          <a:bodyPr/>
+          <p:cNvPr id="2" name="TextBox 1"/>
+          <p:cNvSpPr txBox="1"/>
+          <p:nvPr/>
+        </p:nvSpPr>
+        <p:spPr>
+          <a:xfrm>
+            <a:off x="640080" y="411480"/>
+            <a:ext cx="10972800" cy="502920"/>
+          </a:xfrm>
+          <a:prstGeom prst="rect">
+            <a:avLst/>
+          </a:prstGeom>
+          <a:noFill/>
+        </p:spPr>
+        <p:txBody>
+          <a:bodyPr wrap="none">
+            <a:spAutoFit/>
+          </a:bodyPr>
+          <a:lstStyle/>
+          <a:p>
+            <a:pPr algn="l"/>
+            <a:r>
+              <a:rPr sz="2600" b="1" i="0">
+                <a:latin typeface="Calibri"/>
+              </a:rPr>
+              <a:t>Цел на проекта</a:t>
+            </a:r>
+          </a:p>
+        </p:txBody>
+      </p:sp>
+      <p:sp>
+        <p:nvSpPr>
+          <p:cNvPr id="3" name="Rectangle 2"/>
+          <p:cNvSpPr/>
+          <p:nvPr/>
+        </p:nvSpPr>
+        <p:spPr>
+          <a:xfrm>
+            <a:off x="640080" y="1005840"/>
+            <a:ext cx="10881360" cy="9144"/>
+          </a:xfrm>
+          <a:prstGeom prst="rect">
+            <a:avLst/>
+          </a:prstGeom>
+          <a:solidFill>
+            <a:srgbClr val="000000"/>
+          </a:solidFill>
+          <a:ln>
+            <a:solidFill>
+              <a:srgbClr val="000000"/>
+            </a:solidFill>
+          </a:ln>
+        </p:spPr>
+        <p:style>
+          <a:lnRef idx="1">
+            <a:schemeClr val="accent1"/>
+          </a:lnRef>
+          <a:fillRef idx="3">
+            <a:schemeClr val="accent1"/>
+          </a:fillRef>
+          <a:effectRef idx="2">
+            <a:schemeClr val="accent1"/>
+          </a:effectRef>
+          <a:fontRef idx="minor">
+            <a:schemeClr val="lt1"/>
+          </a:fontRef>
+        </p:style>
+        <p:txBody>
+          <a:bodyPr rtlCol="0" anchor="ctr"/>
+          <a:lstStyle/>
+          <a:p>
+            <a:pPr algn="ctr"/>
+          </a:p>
+        </p:txBody>
+      </p:sp>
+      <p:sp>
+        <p:nvSpPr>
+          <p:cNvPr id="4" name="TextBox 3"/>
+          <p:cNvSpPr txBox="1"/>
+          <p:nvPr/>
+        </p:nvSpPr>
+        <p:spPr>
+          <a:xfrm>
+            <a:off x="868680" y="1325880"/>
+            <a:ext cx="10424160" cy="4754880"/>
+          </a:xfrm>
+          <a:prstGeom prst="rect">
+            <a:avLst/>
+          </a:prstGeom>
+          <a:noFill/>
+        </p:spPr>
+        <p:txBody>
+          <a:bodyPr wrap="square">
+            <a:spAutoFit/>
+          </a:bodyPr>
           <a:lstStyle/>
           <a:p>
             <a:pPr>
-              <a:defRPr sz="2400"/>
+              <a:spcAft>
+                <a:spcPts val="1000"/>
+              </a:spcAft>
+              <a:defRPr sz="2100">
+                <a:latin typeface="Calibri"/>
+              </a:defRPr>
             </a:pPr>
             <a:r>
-              <a:t>CNN + RNN/LSTM encoder-decoder.</a:t>
+              <a:t>Да се разработи уеб приложение, което приема изображение и генерира кратко текстово описание.</a:t>
             </a:r>
           </a:p>
           <a:p>
             <a:pPr>
-              <a:defRPr sz="2400"/>
+              <a:spcAft>
+                <a:spcPts val="1000"/>
+              </a:spcAft>
+              <a:defRPr sz="2100">
+                <a:latin typeface="Calibri"/>
+              </a:defRPr>
             </a:pPr>
             <a:r>
-              <a:t>Attention-based image captioning.</a:t>
+              <a:t>Проектът комбинира обработка на изображения и обработка на естествен език.</a:t>
             </a:r>
           </a:p>
           <a:p>
             <a:pPr>
-              <a:defRPr sz="2400"/>
+              <a:spcAft>
+                <a:spcPts val="1000"/>
+              </a:spcAft>
+              <a:defRPr sz="2100">
+                <a:latin typeface="Calibri"/>
+              </a:defRPr>
             </a:pPr>
             <a:r>
-              <a:t>Transformer-based vision-language модели.</a:t>
+              <a:t>Основният модел е реализиран като encoder-decoder архитектура с VGG16 и LSTM.</a:t>
             </a:r>
           </a:p>
           <a:p>
             <a:pPr>
-              <a:defRPr sz="2400"/>
+              <a:spcAft>
+                <a:spcPts val="1000"/>
+              </a:spcAft>
+              <a:defRPr sz="2100">
+                <a:latin typeface="Calibri"/>
+              </a:defRPr>
             </a:pPr>
             <a:r>
-              <a:t>BLEU и ROUGE-L за автоматична оценка.</a:t>
+              <a:t>Като допълнение са направени сравнения с retrieval подход и предварително обучен модел.</a:t>
+            </a:r>
+          </a:p>
+        </p:txBody>
+      </p:sp>
+      <p:sp>
+        <p:nvSpPr>
+          <p:cNvPr id="5" name="TextBox 4"/>
+          <p:cNvSpPr txBox="1"/>
+          <p:nvPr/>
+        </p:nvSpPr>
+        <p:spPr>
+          <a:xfrm>
+            <a:off x="548640" y="6473952"/>
+            <a:ext cx="5486400" cy="228600"/>
+          </a:xfrm>
+          <a:prstGeom prst="rect">
+            <a:avLst/>
+          </a:prstGeom>
+          <a:noFill/>
+        </p:spPr>
+        <p:txBody>
+          <a:bodyPr wrap="none">
+            <a:spAutoFit/>
+          </a:bodyPr>
+          <a:lstStyle/>
+          <a:p>
+            <a:pPr algn="l"/>
+            <a:r>
+              <a:rPr sz="800" b="0" i="1">
+                <a:latin typeface="Calibri"/>
+              </a:rPr>
+              <a:t>Генериране на описание за изображение</a:t>
+            </a:r>
+          </a:p>
+        </p:txBody>
+      </p:sp>
+      <p:sp>
+        <p:nvSpPr>
+          <p:cNvPr id="6" name="TextBox 5"/>
+          <p:cNvSpPr txBox="1"/>
+          <p:nvPr/>
+        </p:nvSpPr>
+        <p:spPr>
+          <a:xfrm>
+            <a:off x="10972800" y="6473952"/>
+            <a:ext cx="640080" cy="228600"/>
+          </a:xfrm>
+          <a:prstGeom prst="rect">
+            <a:avLst/>
+          </a:prstGeom>
+          <a:noFill/>
+        </p:spPr>
+        <p:txBody>
+          <a:bodyPr wrap="none">
+            <a:spAutoFit/>
+          </a:bodyPr>
+          <a:lstStyle/>
+          <a:p>
+            <a:pPr algn="r"/>
+            <a:r>
+              <a:rPr sz="800" b="0" i="0">
+                <a:latin typeface="Calibri"/>
+              </a:rPr>
+              <a:t>3/15</a:t>
             </a:r>
           </a:p>
         </p:txBody>
@@ -3692,77 +5289,216 @@
       <p:grpSpPr/>
       <p:sp>
         <p:nvSpPr>
-          <p:cNvPr id="2" name="Title 1"/>
-          <p:cNvSpPr>
-            <a:spLocks noGrp="1"/>
-          </p:cNvSpPr>
-          <p:nvPr>
-            <p:ph type="title"/>
-          </p:nvPr>
-        </p:nvSpPr>
-        <p:spPr/>
-        <p:txBody>
-          <a:bodyPr/>
-          <a:lstStyle/>
-          <a:p>
-            <a:r>
-              <a:t>Слайд 4: Данни</a:t>
-            </a:r>
-          </a:p>
-        </p:txBody>
-      </p:sp>
-      <p:sp>
-        <p:nvSpPr>
-          <p:cNvPr id="3" name="Content Placeholder 2"/>
-          <p:cNvSpPr>
-            <a:spLocks noGrp="1"/>
-          </p:cNvSpPr>
-          <p:nvPr>
-            <p:ph idx="1"/>
-          </p:nvPr>
-        </p:nvSpPr>
-        <p:spPr/>
-        <p:txBody>
-          <a:bodyPr/>
+          <p:cNvPr id="2" name="TextBox 1"/>
+          <p:cNvSpPr txBox="1"/>
+          <p:nvPr/>
+        </p:nvSpPr>
+        <p:spPr>
+          <a:xfrm>
+            <a:off x="640080" y="411480"/>
+            <a:ext cx="10972800" cy="502920"/>
+          </a:xfrm>
+          <a:prstGeom prst="rect">
+            <a:avLst/>
+          </a:prstGeom>
+          <a:noFill/>
+        </p:spPr>
+        <p:txBody>
+          <a:bodyPr wrap="none">
+            <a:spAutoFit/>
+          </a:bodyPr>
+          <a:lstStyle/>
+          <a:p>
+            <a:pPr algn="l"/>
+            <a:r>
+              <a:rPr sz="2600" b="1" i="0">
+                <a:latin typeface="Calibri"/>
+              </a:rPr>
+              <a:t>Разучени подходи</a:t>
+            </a:r>
+          </a:p>
+        </p:txBody>
+      </p:sp>
+      <p:sp>
+        <p:nvSpPr>
+          <p:cNvPr id="3" name="Rectangle 2"/>
+          <p:cNvSpPr/>
+          <p:nvPr/>
+        </p:nvSpPr>
+        <p:spPr>
+          <a:xfrm>
+            <a:off x="640080" y="1005840"/>
+            <a:ext cx="10881360" cy="9144"/>
+          </a:xfrm>
+          <a:prstGeom prst="rect">
+            <a:avLst/>
+          </a:prstGeom>
+          <a:solidFill>
+            <a:srgbClr val="000000"/>
+          </a:solidFill>
+          <a:ln>
+            <a:solidFill>
+              <a:srgbClr val="000000"/>
+            </a:solidFill>
+          </a:ln>
+        </p:spPr>
+        <p:style>
+          <a:lnRef idx="1">
+            <a:schemeClr val="accent1"/>
+          </a:lnRef>
+          <a:fillRef idx="3">
+            <a:schemeClr val="accent1"/>
+          </a:fillRef>
+          <a:effectRef idx="2">
+            <a:schemeClr val="accent1"/>
+          </a:effectRef>
+          <a:fontRef idx="minor">
+            <a:schemeClr val="lt1"/>
+          </a:fontRef>
+        </p:style>
+        <p:txBody>
+          <a:bodyPr rtlCol="0" anchor="ctr"/>
+          <a:lstStyle/>
+          <a:p>
+            <a:pPr algn="ctr"/>
+          </a:p>
+        </p:txBody>
+      </p:sp>
+      <p:sp>
+        <p:nvSpPr>
+          <p:cNvPr id="4" name="TextBox 3"/>
+          <p:cNvSpPr txBox="1"/>
+          <p:nvPr/>
+        </p:nvSpPr>
+        <p:spPr>
+          <a:xfrm>
+            <a:off x="868680" y="1325880"/>
+            <a:ext cx="10424160" cy="4754880"/>
+          </a:xfrm>
+          <a:prstGeom prst="rect">
+            <a:avLst/>
+          </a:prstGeom>
+          <a:noFill/>
+        </p:spPr>
+        <p:txBody>
+          <a:bodyPr wrap="square">
+            <a:spAutoFit/>
+          </a:bodyPr>
           <a:lstStyle/>
           <a:p>
             <a:pPr>
-              <a:defRPr sz="2400"/>
+              <a:spcAft>
+                <a:spcPts val="1000"/>
+              </a:spcAft>
+              <a:defRPr sz="2100">
+                <a:latin typeface="Calibri"/>
+              </a:defRPr>
             </a:pPr>
             <a:r>
-              <a:t>Dataset: Flickr8k.</a:t>
+              <a:t>Класически подход: CNN извлича визуални характеристики, а RNN/LSTM генерира изречение дума по дума.</a:t>
             </a:r>
           </a:p>
           <a:p>
             <a:pPr>
-              <a:defRPr sz="2400"/>
+              <a:spcAft>
+                <a:spcPts val="1000"/>
+              </a:spcAft>
+              <a:defRPr sz="2100">
+                <a:latin typeface="Calibri"/>
+              </a:defRPr>
             </a:pPr>
             <a:r>
-              <a:t>8091 изображения.</a:t>
+              <a:t>Attention механизмите подобряват връзката между отделни части от изображението и отделни думи.</a:t>
             </a:r>
           </a:p>
           <a:p>
             <a:pPr>
-              <a:defRPr sz="2400"/>
+              <a:spcAft>
+                <a:spcPts val="1000"/>
+              </a:spcAft>
+              <a:defRPr sz="2100">
+                <a:latin typeface="Calibri"/>
+              </a:defRPr>
             </a:pPr>
             <a:r>
-              <a:t>40455 captions.</a:t>
+              <a:t>Transformer-базираните vision-language модели обикновено дават по-добри резултати, но са по-тежки.</a:t>
             </a:r>
           </a:p>
           <a:p>
             <a:pPr>
-              <a:defRPr sz="2400"/>
+              <a:spcAft>
+                <a:spcPts val="1000"/>
+              </a:spcAft>
+              <a:defRPr sz="2100">
+                <a:latin typeface="Calibri"/>
+              </a:defRPr>
             </a:pPr>
             <a:r>
-              <a:t>Средно около 5 captions на изображение.</a:t>
-            </a:r>
-          </a:p>
-          <a:p>
-            <a:pPr>
-              <a:defRPr sz="2400"/>
-            </a:pPr>
-            <a:r>
-              <a:t>Проверени са липсващи изображения, празни captions и дубликати.</a:t>
+              <a:t>За оценка се използват автоматични метрики като BLEU и ROUGE-L, както и качествен преглед на примери.</a:t>
+            </a:r>
+          </a:p>
+        </p:txBody>
+      </p:sp>
+      <p:sp>
+        <p:nvSpPr>
+          <p:cNvPr id="5" name="TextBox 4"/>
+          <p:cNvSpPr txBox="1"/>
+          <p:nvPr/>
+        </p:nvSpPr>
+        <p:spPr>
+          <a:xfrm>
+            <a:off x="548640" y="6473952"/>
+            <a:ext cx="5486400" cy="228600"/>
+          </a:xfrm>
+          <a:prstGeom prst="rect">
+            <a:avLst/>
+          </a:prstGeom>
+          <a:noFill/>
+        </p:spPr>
+        <p:txBody>
+          <a:bodyPr wrap="none">
+            <a:spAutoFit/>
+          </a:bodyPr>
+          <a:lstStyle/>
+          <a:p>
+            <a:pPr algn="l"/>
+            <a:r>
+              <a:rPr sz="800" b="0" i="1">
+                <a:latin typeface="Calibri"/>
+              </a:rPr>
+              <a:t>Генериране на описание за изображение</a:t>
+            </a:r>
+          </a:p>
+        </p:txBody>
+      </p:sp>
+      <p:sp>
+        <p:nvSpPr>
+          <p:cNvPr id="6" name="TextBox 5"/>
+          <p:cNvSpPr txBox="1"/>
+          <p:nvPr/>
+        </p:nvSpPr>
+        <p:spPr>
+          <a:xfrm>
+            <a:off x="10972800" y="6473952"/>
+            <a:ext cx="640080" cy="228600"/>
+          </a:xfrm>
+          <a:prstGeom prst="rect">
+            <a:avLst/>
+          </a:prstGeom>
+          <a:noFill/>
+        </p:spPr>
+        <p:txBody>
+          <a:bodyPr wrap="none">
+            <a:spAutoFit/>
+          </a:bodyPr>
+          <a:lstStyle/>
+          <a:p>
+            <a:pPr algn="r"/>
+            <a:r>
+              <a:rPr sz="800" b="0" i="0">
+                <a:latin typeface="Calibri"/>
+              </a:rPr>
+              <a:t>4/15</a:t>
             </a:r>
           </a:p>
         </p:txBody>
@@ -3787,69 +5523,216 @@
       <p:grpSpPr/>
       <p:sp>
         <p:nvSpPr>
-          <p:cNvPr id="2" name="Title 1"/>
-          <p:cNvSpPr>
-            <a:spLocks noGrp="1"/>
-          </p:cNvSpPr>
-          <p:nvPr>
-            <p:ph type="title"/>
-          </p:nvPr>
-        </p:nvSpPr>
-        <p:spPr/>
-        <p:txBody>
-          <a:bodyPr/>
-          <a:lstStyle/>
-          <a:p>
-            <a:r>
-              <a:t>Слайд 5: EDA</a:t>
-            </a:r>
-          </a:p>
-        </p:txBody>
-      </p:sp>
-      <p:sp>
-        <p:nvSpPr>
-          <p:cNvPr id="3" name="Content Placeholder 2"/>
-          <p:cNvSpPr>
-            <a:spLocks noGrp="1"/>
-          </p:cNvSpPr>
-          <p:nvPr>
-            <p:ph idx="1"/>
-          </p:nvPr>
-        </p:nvSpPr>
-        <p:spPr/>
-        <p:txBody>
-          <a:bodyPr/>
+          <p:cNvPr id="2" name="TextBox 1"/>
+          <p:cNvSpPr txBox="1"/>
+          <p:nvPr/>
+        </p:nvSpPr>
+        <p:spPr>
+          <a:xfrm>
+            <a:off x="640080" y="411480"/>
+            <a:ext cx="10972800" cy="502920"/>
+          </a:xfrm>
+          <a:prstGeom prst="rect">
+            <a:avLst/>
+          </a:prstGeom>
+          <a:noFill/>
+        </p:spPr>
+        <p:txBody>
+          <a:bodyPr wrap="none">
+            <a:spAutoFit/>
+          </a:bodyPr>
+          <a:lstStyle/>
+          <a:p>
+            <a:pPr algn="l"/>
+            <a:r>
+              <a:rPr sz="2600" b="1" i="0">
+                <a:latin typeface="Calibri"/>
+              </a:rPr>
+              <a:t>Набор от данни</a:t>
+            </a:r>
+          </a:p>
+        </p:txBody>
+      </p:sp>
+      <p:sp>
+        <p:nvSpPr>
+          <p:cNvPr id="3" name="Rectangle 2"/>
+          <p:cNvSpPr/>
+          <p:nvPr/>
+        </p:nvSpPr>
+        <p:spPr>
+          <a:xfrm>
+            <a:off x="640080" y="1005840"/>
+            <a:ext cx="10881360" cy="9144"/>
+          </a:xfrm>
+          <a:prstGeom prst="rect">
+            <a:avLst/>
+          </a:prstGeom>
+          <a:solidFill>
+            <a:srgbClr val="000000"/>
+          </a:solidFill>
+          <a:ln>
+            <a:solidFill>
+              <a:srgbClr val="000000"/>
+            </a:solidFill>
+          </a:ln>
+        </p:spPr>
+        <p:style>
+          <a:lnRef idx="1">
+            <a:schemeClr val="accent1"/>
+          </a:lnRef>
+          <a:fillRef idx="3">
+            <a:schemeClr val="accent1"/>
+          </a:fillRef>
+          <a:effectRef idx="2">
+            <a:schemeClr val="accent1"/>
+          </a:effectRef>
+          <a:fontRef idx="minor">
+            <a:schemeClr val="lt1"/>
+          </a:fontRef>
+        </p:style>
+        <p:txBody>
+          <a:bodyPr rtlCol="0" anchor="ctr"/>
+          <a:lstStyle/>
+          <a:p>
+            <a:pPr algn="ctr"/>
+          </a:p>
+        </p:txBody>
+      </p:sp>
+      <p:sp>
+        <p:nvSpPr>
+          <p:cNvPr id="4" name="TextBox 3"/>
+          <p:cNvSpPr txBox="1"/>
+          <p:nvPr/>
+        </p:nvSpPr>
+        <p:spPr>
+          <a:xfrm>
+            <a:off x="868680" y="1325880"/>
+            <a:ext cx="10424160" cy="4754880"/>
+          </a:xfrm>
+          <a:prstGeom prst="rect">
+            <a:avLst/>
+          </a:prstGeom>
+          <a:noFill/>
+        </p:spPr>
+        <p:txBody>
+          <a:bodyPr wrap="square">
+            <a:spAutoFit/>
+          </a:bodyPr>
           <a:lstStyle/>
           <a:p>
             <a:pPr>
-              <a:defRPr sz="2400"/>
+              <a:spcAft>
+                <a:spcPts val="1000"/>
+              </a:spcAft>
+              <a:defRPr sz="2100">
+                <a:latin typeface="Calibri"/>
+              </a:defRPr>
             </a:pPr>
             <a:r>
-              <a:t>Анализирах дължина на captions.</a:t>
+              <a:t>Използван е Flickr8k.</a:t>
             </a:r>
           </a:p>
           <a:p>
             <a:pPr>
-              <a:defRPr sz="2400"/>
+              <a:spcAft>
+                <a:spcPts val="1000"/>
+              </a:spcAft>
+              <a:defRPr sz="2100">
+                <a:latin typeface="Calibri"/>
+              </a:defRPr>
             </a:pPr>
             <a:r>
-              <a:t>Проверих най-чести думи.</a:t>
+              <a:t>Наборът съдържа 8091 изображения от ежедневни сцени.</a:t>
             </a:r>
           </a:p>
           <a:p>
             <a:pPr>
-              <a:defRPr sz="2400"/>
+              <a:spcAft>
+                <a:spcPts val="1000"/>
+              </a:spcAft>
+              <a:defRPr sz="2100">
+                <a:latin typeface="Calibri"/>
+              </a:defRPr>
             </a:pPr>
             <a:r>
-              <a:t>Проверих размери и aspect ratio на изображенията.</a:t>
+              <a:t>За всяко изображение има приблизително пет човешки описания.</a:t>
             </a:r>
           </a:p>
           <a:p>
             <a:pPr>
-              <a:defRPr sz="2400"/>
+              <a:spcAft>
+                <a:spcPts val="1000"/>
+              </a:spcAft>
+              <a:defRPr sz="2100">
+                <a:latin typeface="Calibri"/>
+              </a:defRPr>
             </a:pPr>
             <a:r>
-              <a:t>Използвах визуализации за текстовите и image статистиките.</a:t>
+              <a:t>Данните са разделени на train, validation и test по уникални изображения, за да няма изтичане между частите.</a:t>
+            </a:r>
+          </a:p>
+        </p:txBody>
+      </p:sp>
+      <p:sp>
+        <p:nvSpPr>
+          <p:cNvPr id="5" name="TextBox 4"/>
+          <p:cNvSpPr txBox="1"/>
+          <p:nvPr/>
+        </p:nvSpPr>
+        <p:spPr>
+          <a:xfrm>
+            <a:off x="548640" y="6473952"/>
+            <a:ext cx="5486400" cy="228600"/>
+          </a:xfrm>
+          <a:prstGeom prst="rect">
+            <a:avLst/>
+          </a:prstGeom>
+          <a:noFill/>
+        </p:spPr>
+        <p:txBody>
+          <a:bodyPr wrap="none">
+            <a:spAutoFit/>
+          </a:bodyPr>
+          <a:lstStyle/>
+          <a:p>
+            <a:pPr algn="l"/>
+            <a:r>
+              <a:rPr sz="800" b="0" i="1">
+                <a:latin typeface="Calibri"/>
+              </a:rPr>
+              <a:t>Генериране на описание за изображение</a:t>
+            </a:r>
+          </a:p>
+        </p:txBody>
+      </p:sp>
+      <p:sp>
+        <p:nvSpPr>
+          <p:cNvPr id="6" name="TextBox 5"/>
+          <p:cNvSpPr txBox="1"/>
+          <p:nvPr/>
+        </p:nvSpPr>
+        <p:spPr>
+          <a:xfrm>
+            <a:off x="10972800" y="6473952"/>
+            <a:ext cx="640080" cy="228600"/>
+          </a:xfrm>
+          <a:prstGeom prst="rect">
+            <a:avLst/>
+          </a:prstGeom>
+          <a:noFill/>
+        </p:spPr>
+        <p:txBody>
+          <a:bodyPr wrap="none">
+            <a:spAutoFit/>
+          </a:bodyPr>
+          <a:lstStyle/>
+          <a:p>
+            <a:pPr algn="r"/>
+            <a:r>
+              <a:rPr sz="800" b="0" i="0">
+                <a:latin typeface="Calibri"/>
+              </a:rPr>
+              <a:t>5/15</a:t>
             </a:r>
           </a:p>
         </p:txBody>
@@ -3874,69 +5757,216 @@
       <p:grpSpPr/>
       <p:sp>
         <p:nvSpPr>
-          <p:cNvPr id="2" name="Title 1"/>
-          <p:cNvSpPr>
-            <a:spLocks noGrp="1"/>
-          </p:cNvSpPr>
-          <p:nvPr>
-            <p:ph type="title"/>
-          </p:nvPr>
-        </p:nvSpPr>
-        <p:spPr/>
-        <p:txBody>
-          <a:bodyPr/>
-          <a:lstStyle/>
-          <a:p>
-            <a:r>
-              <a:t>Слайд 6: Preprocessing</a:t>
-            </a:r>
-          </a:p>
-        </p:txBody>
-      </p:sp>
-      <p:sp>
-        <p:nvSpPr>
-          <p:cNvPr id="3" name="Content Placeholder 2"/>
-          <p:cNvSpPr>
-            <a:spLocks noGrp="1"/>
-          </p:cNvSpPr>
-          <p:nvPr>
-            <p:ph idx="1"/>
-          </p:nvPr>
-        </p:nvSpPr>
-        <p:spPr/>
-        <p:txBody>
-          <a:bodyPr/>
+          <p:cNvPr id="2" name="TextBox 1"/>
+          <p:cNvSpPr txBox="1"/>
+          <p:nvPr/>
+        </p:nvSpPr>
+        <p:spPr>
+          <a:xfrm>
+            <a:off x="640080" y="411480"/>
+            <a:ext cx="10972800" cy="502920"/>
+          </a:xfrm>
+          <a:prstGeom prst="rect">
+            <a:avLst/>
+          </a:prstGeom>
+          <a:noFill/>
+        </p:spPr>
+        <p:txBody>
+          <a:bodyPr wrap="none">
+            <a:spAutoFit/>
+          </a:bodyPr>
+          <a:lstStyle/>
+          <a:p>
+            <a:pPr algn="l"/>
+            <a:r>
+              <a:rPr sz="2600" b="1" i="0">
+                <a:latin typeface="Calibri"/>
+              </a:rPr>
+              <a:t>Разглеждане на данните</a:t>
+            </a:r>
+          </a:p>
+        </p:txBody>
+      </p:sp>
+      <p:sp>
+        <p:nvSpPr>
+          <p:cNvPr id="3" name="Rectangle 2"/>
+          <p:cNvSpPr/>
+          <p:nvPr/>
+        </p:nvSpPr>
+        <p:spPr>
+          <a:xfrm>
+            <a:off x="640080" y="1005840"/>
+            <a:ext cx="10881360" cy="9144"/>
+          </a:xfrm>
+          <a:prstGeom prst="rect">
+            <a:avLst/>
+          </a:prstGeom>
+          <a:solidFill>
+            <a:srgbClr val="000000"/>
+          </a:solidFill>
+          <a:ln>
+            <a:solidFill>
+              <a:srgbClr val="000000"/>
+            </a:solidFill>
+          </a:ln>
+        </p:spPr>
+        <p:style>
+          <a:lnRef idx="1">
+            <a:schemeClr val="accent1"/>
+          </a:lnRef>
+          <a:fillRef idx="3">
+            <a:schemeClr val="accent1"/>
+          </a:fillRef>
+          <a:effectRef idx="2">
+            <a:schemeClr val="accent1"/>
+          </a:effectRef>
+          <a:fontRef idx="minor">
+            <a:schemeClr val="lt1"/>
+          </a:fontRef>
+        </p:style>
+        <p:txBody>
+          <a:bodyPr rtlCol="0" anchor="ctr"/>
+          <a:lstStyle/>
+          <a:p>
+            <a:pPr algn="ctr"/>
+          </a:p>
+        </p:txBody>
+      </p:sp>
+      <p:sp>
+        <p:nvSpPr>
+          <p:cNvPr id="4" name="TextBox 3"/>
+          <p:cNvSpPr txBox="1"/>
+          <p:nvPr/>
+        </p:nvSpPr>
+        <p:spPr>
+          <a:xfrm>
+            <a:off x="868680" y="1325880"/>
+            <a:ext cx="10424160" cy="4754880"/>
+          </a:xfrm>
+          <a:prstGeom prst="rect">
+            <a:avLst/>
+          </a:prstGeom>
+          <a:noFill/>
+        </p:spPr>
+        <p:txBody>
+          <a:bodyPr wrap="square">
+            <a:spAutoFit/>
+          </a:bodyPr>
           <a:lstStyle/>
           <a:p>
             <a:pPr>
-              <a:defRPr sz="2400"/>
+              <a:spcAft>
+                <a:spcPts val="1000"/>
+              </a:spcAft>
+              <a:defRPr sz="2100">
+                <a:latin typeface="Calibri"/>
+              </a:defRPr>
             </a:pPr>
             <a:r>
-              <a:t>Resize до `224x224`.</a:t>
+              <a:t>Проверени са липсващи изображения, празни описания и повторения.</a:t>
             </a:r>
           </a:p>
           <a:p>
             <a:pPr>
-              <a:defRPr sz="2400"/>
+              <a:spcAft>
+                <a:spcPts val="1000"/>
+              </a:spcAft>
+              <a:defRPr sz="2100">
+                <a:latin typeface="Calibri"/>
+              </a:defRPr>
             </a:pPr>
             <a:r>
-              <a:t>ImageNet normalization.</a:t>
+              <a:t>Анализирана е дължината на описанията и най-често срещаните думи.</a:t>
             </a:r>
           </a:p>
           <a:p>
             <a:pPr>
-              <a:defRPr sz="2400"/>
+              <a:spcAft>
+                <a:spcPts val="1000"/>
+              </a:spcAft>
+              <a:defRPr sz="2100">
+                <a:latin typeface="Calibri"/>
+              </a:defRPr>
             </a:pPr>
             <a:r>
-              <a:t>Train augmentation: random horizontal flip и random rotation.</a:t>
+              <a:t>Разгледани са размерите на изображенията и съотношението ширина към височина.</a:t>
             </a:r>
           </a:p>
           <a:p>
             <a:pPr>
-              <a:defRPr sz="2400"/>
+              <a:spcAft>
+                <a:spcPts val="1000"/>
+              </a:spcAft>
+              <a:defRPr sz="2100">
+                <a:latin typeface="Calibri"/>
+              </a:defRPr>
             </a:pPr>
             <a:r>
-              <a:t>Validation/test preprocessing е детерминиран.</a:t>
+              <a:t>Визуализациите са използвани, за да се види дали има очевидни аномалии в данните.</a:t>
+            </a:r>
+          </a:p>
+        </p:txBody>
+      </p:sp>
+      <p:sp>
+        <p:nvSpPr>
+          <p:cNvPr id="5" name="TextBox 4"/>
+          <p:cNvSpPr txBox="1"/>
+          <p:nvPr/>
+        </p:nvSpPr>
+        <p:spPr>
+          <a:xfrm>
+            <a:off x="548640" y="6473952"/>
+            <a:ext cx="5486400" cy="228600"/>
+          </a:xfrm>
+          <a:prstGeom prst="rect">
+            <a:avLst/>
+          </a:prstGeom>
+          <a:noFill/>
+        </p:spPr>
+        <p:txBody>
+          <a:bodyPr wrap="none">
+            <a:spAutoFit/>
+          </a:bodyPr>
+          <a:lstStyle/>
+          <a:p>
+            <a:pPr algn="l"/>
+            <a:r>
+              <a:rPr sz="800" b="0" i="1">
+                <a:latin typeface="Calibri"/>
+              </a:rPr>
+              <a:t>Генериране на описание за изображение</a:t>
+            </a:r>
+          </a:p>
+        </p:txBody>
+      </p:sp>
+      <p:sp>
+        <p:nvSpPr>
+          <p:cNvPr id="6" name="TextBox 5"/>
+          <p:cNvSpPr txBox="1"/>
+          <p:nvPr/>
+        </p:nvSpPr>
+        <p:spPr>
+          <a:xfrm>
+            <a:off x="10972800" y="6473952"/>
+            <a:ext cx="640080" cy="228600"/>
+          </a:xfrm>
+          <a:prstGeom prst="rect">
+            <a:avLst/>
+          </a:prstGeom>
+          <a:noFill/>
+        </p:spPr>
+        <p:txBody>
+          <a:bodyPr wrap="none">
+            <a:spAutoFit/>
+          </a:bodyPr>
+          <a:lstStyle/>
+          <a:p>
+            <a:pPr algn="r"/>
+            <a:r>
+              <a:rPr sz="800" b="0" i="0">
+                <a:latin typeface="Calibri"/>
+              </a:rPr>
+              <a:t>6/15</a:t>
             </a:r>
           </a:p>
         </p:txBody>
@@ -3961,77 +5991,216 @@
       <p:grpSpPr/>
       <p:sp>
         <p:nvSpPr>
-          <p:cNvPr id="2" name="Title 1"/>
-          <p:cNvSpPr>
-            <a:spLocks noGrp="1"/>
-          </p:cNvSpPr>
-          <p:nvPr>
-            <p:ph type="title"/>
-          </p:nvPr>
-        </p:nvSpPr>
-        <p:spPr/>
-        <p:txBody>
-          <a:bodyPr/>
-          <a:lstStyle/>
-          <a:p>
-            <a:r>
-              <a:t>Слайд 7: Модел</a:t>
-            </a:r>
-          </a:p>
-        </p:txBody>
-      </p:sp>
-      <p:sp>
-        <p:nvSpPr>
-          <p:cNvPr id="3" name="Content Placeholder 2"/>
-          <p:cNvSpPr>
-            <a:spLocks noGrp="1"/>
-          </p:cNvSpPr>
-          <p:nvPr>
-            <p:ph idx="1"/>
-          </p:nvPr>
-        </p:nvSpPr>
-        <p:spPr/>
-        <p:txBody>
-          <a:bodyPr/>
+          <p:cNvPr id="2" name="TextBox 1"/>
+          <p:cNvSpPr txBox="1"/>
+          <p:nvPr/>
+        </p:nvSpPr>
+        <p:spPr>
+          <a:xfrm>
+            <a:off x="640080" y="411480"/>
+            <a:ext cx="10972800" cy="502920"/>
+          </a:xfrm>
+          <a:prstGeom prst="rect">
+            <a:avLst/>
+          </a:prstGeom>
+          <a:noFill/>
+        </p:spPr>
+        <p:txBody>
+          <a:bodyPr wrap="none">
+            <a:spAutoFit/>
+          </a:bodyPr>
+          <a:lstStyle/>
+          <a:p>
+            <a:pPr algn="l"/>
+            <a:r>
+              <a:rPr sz="2600" b="1" i="0">
+                <a:latin typeface="Calibri"/>
+              </a:rPr>
+              <a:t>Предварителна обработка</a:t>
+            </a:r>
+          </a:p>
+        </p:txBody>
+      </p:sp>
+      <p:sp>
+        <p:nvSpPr>
+          <p:cNvPr id="3" name="Rectangle 2"/>
+          <p:cNvSpPr/>
+          <p:nvPr/>
+        </p:nvSpPr>
+        <p:spPr>
+          <a:xfrm>
+            <a:off x="640080" y="1005840"/>
+            <a:ext cx="10881360" cy="9144"/>
+          </a:xfrm>
+          <a:prstGeom prst="rect">
+            <a:avLst/>
+          </a:prstGeom>
+          <a:solidFill>
+            <a:srgbClr val="000000"/>
+          </a:solidFill>
+          <a:ln>
+            <a:solidFill>
+              <a:srgbClr val="000000"/>
+            </a:solidFill>
+          </a:ln>
+        </p:spPr>
+        <p:style>
+          <a:lnRef idx="1">
+            <a:schemeClr val="accent1"/>
+          </a:lnRef>
+          <a:fillRef idx="3">
+            <a:schemeClr val="accent1"/>
+          </a:fillRef>
+          <a:effectRef idx="2">
+            <a:schemeClr val="accent1"/>
+          </a:effectRef>
+          <a:fontRef idx="minor">
+            <a:schemeClr val="lt1"/>
+          </a:fontRef>
+        </p:style>
+        <p:txBody>
+          <a:bodyPr rtlCol="0" anchor="ctr"/>
+          <a:lstStyle/>
+          <a:p>
+            <a:pPr algn="ctr"/>
+          </a:p>
+        </p:txBody>
+      </p:sp>
+      <p:sp>
+        <p:nvSpPr>
+          <p:cNvPr id="4" name="TextBox 3"/>
+          <p:cNvSpPr txBox="1"/>
+          <p:nvPr/>
+        </p:nvSpPr>
+        <p:spPr>
+          <a:xfrm>
+            <a:off x="868680" y="1325880"/>
+            <a:ext cx="10424160" cy="4754880"/>
+          </a:xfrm>
+          <a:prstGeom prst="rect">
+            <a:avLst/>
+          </a:prstGeom>
+          <a:noFill/>
+        </p:spPr>
+        <p:txBody>
+          <a:bodyPr wrap="square">
+            <a:spAutoFit/>
+          </a:bodyPr>
           <a:lstStyle/>
           <a:p>
             <a:pPr>
-              <a:defRPr sz="2400"/>
+              <a:spcAft>
+                <a:spcPts val="1000"/>
+              </a:spcAft>
+              <a:defRPr sz="2100">
+                <a:latin typeface="Calibri"/>
+              </a:defRPr>
             </a:pPr>
             <a:r>
-              <a:t>Encoder: предварително обучен VGG16.</a:t>
+              <a:t>Изображенията се преоразмеряват до 224 x 224 пиксела.</a:t>
             </a:r>
           </a:p>
           <a:p>
             <a:pPr>
-              <a:defRPr sz="2400"/>
+              <a:spcAft>
+                <a:spcPts val="1000"/>
+              </a:spcAft>
+              <a:defRPr sz="2100">
+                <a:latin typeface="Calibri"/>
+              </a:defRPr>
             </a:pPr>
             <a:r>
-              <a:t>Decoder: LSTM.</a:t>
+              <a:t>Използва се нормализация със средни стойности и стандартни отклонения от ImageNet.</a:t>
             </a:r>
           </a:p>
           <a:p>
             <a:pPr>
-              <a:defRPr sz="2400"/>
+              <a:spcAft>
+                <a:spcPts val="1000"/>
+              </a:spcAft>
+              <a:defRPr sz="2100">
+                <a:latin typeface="Calibri"/>
+              </a:defRPr>
             </a:pPr>
             <a:r>
-              <a:t>Word representation: обучаем `Embedding` слой.</a:t>
+              <a:t>При обучението се използват леки augmentation операции като обръщане по хоризонтала и ротация.</a:t>
             </a:r>
           </a:p>
           <a:p>
             <a:pPr>
-              <a:defRPr sz="2400"/>
+              <a:spcAft>
+                <a:spcPts val="1000"/>
+              </a:spcAft>
+              <a:defRPr sz="2100">
+                <a:latin typeface="Calibri"/>
+              </a:defRPr>
             </a:pPr>
             <a:r>
-              <a:t>Кеширах VGG features, за да ускоря обучението.</a:t>
-            </a:r>
-          </a:p>
-          <a:p>
-            <a:pPr>
-              <a:defRPr sz="2400"/>
-            </a:pPr>
-            <a:r>
-              <a:t>Използвах и VGG retrieval вариант за по-заземени captions.</a:t>
+              <a:t>При validation и test обработката е детерминирана, за да се сравняват резултатите коректно.</a:t>
+            </a:r>
+          </a:p>
+        </p:txBody>
+      </p:sp>
+      <p:sp>
+        <p:nvSpPr>
+          <p:cNvPr id="5" name="TextBox 4"/>
+          <p:cNvSpPr txBox="1"/>
+          <p:nvPr/>
+        </p:nvSpPr>
+        <p:spPr>
+          <a:xfrm>
+            <a:off x="548640" y="6473952"/>
+            <a:ext cx="5486400" cy="228600"/>
+          </a:xfrm>
+          <a:prstGeom prst="rect">
+            <a:avLst/>
+          </a:prstGeom>
+          <a:noFill/>
+        </p:spPr>
+        <p:txBody>
+          <a:bodyPr wrap="none">
+            <a:spAutoFit/>
+          </a:bodyPr>
+          <a:lstStyle/>
+          <a:p>
+            <a:pPr algn="l"/>
+            <a:r>
+              <a:rPr sz="800" b="0" i="1">
+                <a:latin typeface="Calibri"/>
+              </a:rPr>
+              <a:t>Генериране на описание за изображение</a:t>
+            </a:r>
+          </a:p>
+        </p:txBody>
+      </p:sp>
+      <p:sp>
+        <p:nvSpPr>
+          <p:cNvPr id="6" name="TextBox 5"/>
+          <p:cNvSpPr txBox="1"/>
+          <p:nvPr/>
+        </p:nvSpPr>
+        <p:spPr>
+          <a:xfrm>
+            <a:off x="10972800" y="6473952"/>
+            <a:ext cx="640080" cy="228600"/>
+          </a:xfrm>
+          <a:prstGeom prst="rect">
+            <a:avLst/>
+          </a:prstGeom>
+          <a:noFill/>
+        </p:spPr>
+        <p:txBody>
+          <a:bodyPr wrap="none">
+            <a:spAutoFit/>
+          </a:bodyPr>
+          <a:lstStyle/>
+          <a:p>
+            <a:pPr algn="r"/>
+            <a:r>
+              <a:rPr sz="800" b="0" i="0">
+                <a:latin typeface="Calibri"/>
+              </a:rPr>
+              <a:t>7/15</a:t>
             </a:r>
           </a:p>
         </p:txBody>
@@ -4056,69 +6225,216 @@
       <p:grpSpPr/>
       <p:sp>
         <p:nvSpPr>
-          <p:cNvPr id="2" name="Title 1"/>
-          <p:cNvSpPr>
-            <a:spLocks noGrp="1"/>
-          </p:cNvSpPr>
-          <p:nvPr>
-            <p:ph type="title"/>
-          </p:nvPr>
-        </p:nvSpPr>
-        <p:spPr/>
-        <p:txBody>
-          <a:bodyPr/>
-          <a:lstStyle/>
-          <a:p>
-            <a:r>
-              <a:t>Слайд 8: Обучение и оценка</a:t>
-            </a:r>
-          </a:p>
-        </p:txBody>
-      </p:sp>
-      <p:sp>
-        <p:nvSpPr>
-          <p:cNvPr id="3" name="Content Placeholder 2"/>
-          <p:cNvSpPr>
-            <a:spLocks noGrp="1"/>
-          </p:cNvSpPr>
-          <p:nvPr>
-            <p:ph idx="1"/>
-          </p:nvPr>
-        </p:nvSpPr>
-        <p:spPr/>
-        <p:txBody>
-          <a:bodyPr/>
+          <p:cNvPr id="2" name="TextBox 1"/>
+          <p:cNvSpPr txBox="1"/>
+          <p:nvPr/>
+        </p:nvSpPr>
+        <p:spPr>
+          <a:xfrm>
+            <a:off x="640080" y="411480"/>
+            <a:ext cx="10972800" cy="502920"/>
+          </a:xfrm>
+          <a:prstGeom prst="rect">
+            <a:avLst/>
+          </a:prstGeom>
+          <a:noFill/>
+        </p:spPr>
+        <p:txBody>
+          <a:bodyPr wrap="none">
+            <a:spAutoFit/>
+          </a:bodyPr>
+          <a:lstStyle/>
+          <a:p>
+            <a:pPr algn="l"/>
+            <a:r>
+              <a:rPr sz="2600" b="1" i="0">
+                <a:latin typeface="Calibri"/>
+              </a:rPr>
+              <a:t>Текстова обработка</a:t>
+            </a:r>
+          </a:p>
+        </p:txBody>
+      </p:sp>
+      <p:sp>
+        <p:nvSpPr>
+          <p:cNvPr id="3" name="Rectangle 2"/>
+          <p:cNvSpPr/>
+          <p:nvPr/>
+        </p:nvSpPr>
+        <p:spPr>
+          <a:xfrm>
+            <a:off x="640080" y="1005840"/>
+            <a:ext cx="10881360" cy="9144"/>
+          </a:xfrm>
+          <a:prstGeom prst="rect">
+            <a:avLst/>
+          </a:prstGeom>
+          <a:solidFill>
+            <a:srgbClr val="000000"/>
+          </a:solidFill>
+          <a:ln>
+            <a:solidFill>
+              <a:srgbClr val="000000"/>
+            </a:solidFill>
+          </a:ln>
+        </p:spPr>
+        <p:style>
+          <a:lnRef idx="1">
+            <a:schemeClr val="accent1"/>
+          </a:lnRef>
+          <a:fillRef idx="3">
+            <a:schemeClr val="accent1"/>
+          </a:fillRef>
+          <a:effectRef idx="2">
+            <a:schemeClr val="accent1"/>
+          </a:effectRef>
+          <a:fontRef idx="minor">
+            <a:schemeClr val="lt1"/>
+          </a:fontRef>
+        </p:style>
+        <p:txBody>
+          <a:bodyPr rtlCol="0" anchor="ctr"/>
+          <a:lstStyle/>
+          <a:p>
+            <a:pPr algn="ctr"/>
+          </a:p>
+        </p:txBody>
+      </p:sp>
+      <p:sp>
+        <p:nvSpPr>
+          <p:cNvPr id="4" name="TextBox 3"/>
+          <p:cNvSpPr txBox="1"/>
+          <p:nvPr/>
+        </p:nvSpPr>
+        <p:spPr>
+          <a:xfrm>
+            <a:off x="868680" y="1325880"/>
+            <a:ext cx="10424160" cy="4754880"/>
+          </a:xfrm>
+          <a:prstGeom prst="rect">
+            <a:avLst/>
+          </a:prstGeom>
+          <a:noFill/>
+        </p:spPr>
+        <p:txBody>
+          <a:bodyPr wrap="square">
+            <a:spAutoFit/>
+          </a:bodyPr>
           <a:lstStyle/>
           <a:p>
             <a:pPr>
-              <a:defRPr sz="2400"/>
+              <a:spcAft>
+                <a:spcPts val="1000"/>
+              </a:spcAft>
+              <a:defRPr sz="2100">
+                <a:latin typeface="Calibri"/>
+              </a:defRPr>
             </a:pPr>
             <a:r>
-              <a:t>Split: train / validation / test по уникални изображения.</a:t>
+              <a:t>Описанията се почистват и токенизират.</a:t>
             </a:r>
           </a:p>
           <a:p>
             <a:pPr>
-              <a:defRPr sz="2400"/>
+              <a:spcAft>
+                <a:spcPts val="1000"/>
+              </a:spcAft>
+              <a:defRPr sz="2100">
+                <a:latin typeface="Calibri"/>
+              </a:defRPr>
             </a:pPr>
             <a:r>
-              <a:t>Loss: cross-entropy върху следващата дума.</a:t>
+              <a:t>Изграден е речник от думите, които се срещат достатъчно често в training частта.</a:t>
             </a:r>
           </a:p>
           <a:p>
             <a:pPr>
-              <a:defRPr sz="2400"/>
+              <a:spcAft>
+                <a:spcPts val="1000"/>
+              </a:spcAft>
+              <a:defRPr sz="2100">
+                <a:latin typeface="Calibri"/>
+              </a:defRPr>
             </a:pPr>
             <a:r>
-              <a:t>Метрики: BLEU-1, BLEU-4, ROUGE-L.</a:t>
+              <a:t>Добавени са специални токени за начало, край, padding и непозната дума.</a:t>
             </a:r>
           </a:p>
           <a:p>
             <a:pPr>
-              <a:defRPr sz="2400"/>
+              <a:spcAft>
+                <a:spcPts val="1000"/>
+              </a:spcAft>
+              <a:defRPr sz="2100">
+                <a:latin typeface="Calibri"/>
+              </a:defRPr>
             </a:pPr>
             <a:r>
-              <a:t>Най-добрият checkpoint е избран по validation loss.</a:t>
+              <a:t>Думите в основния модел се представят чрез обучаем Embedding слой.</a:t>
+            </a:r>
+          </a:p>
+        </p:txBody>
+      </p:sp>
+      <p:sp>
+        <p:nvSpPr>
+          <p:cNvPr id="5" name="TextBox 4"/>
+          <p:cNvSpPr txBox="1"/>
+          <p:nvPr/>
+        </p:nvSpPr>
+        <p:spPr>
+          <a:xfrm>
+            <a:off x="548640" y="6473952"/>
+            <a:ext cx="5486400" cy="228600"/>
+          </a:xfrm>
+          <a:prstGeom prst="rect">
+            <a:avLst/>
+          </a:prstGeom>
+          <a:noFill/>
+        </p:spPr>
+        <p:txBody>
+          <a:bodyPr wrap="none">
+            <a:spAutoFit/>
+          </a:bodyPr>
+          <a:lstStyle/>
+          <a:p>
+            <a:pPr algn="l"/>
+            <a:r>
+              <a:rPr sz="800" b="0" i="1">
+                <a:latin typeface="Calibri"/>
+              </a:rPr>
+              <a:t>Генериране на описание за изображение</a:t>
+            </a:r>
+          </a:p>
+        </p:txBody>
+      </p:sp>
+      <p:sp>
+        <p:nvSpPr>
+          <p:cNvPr id="6" name="TextBox 5"/>
+          <p:cNvSpPr txBox="1"/>
+          <p:nvPr/>
+        </p:nvSpPr>
+        <p:spPr>
+          <a:xfrm>
+            <a:off x="10972800" y="6473952"/>
+            <a:ext cx="640080" cy="228600"/>
+          </a:xfrm>
+          <a:prstGeom prst="rect">
+            <a:avLst/>
+          </a:prstGeom>
+          <a:noFill/>
+        </p:spPr>
+        <p:txBody>
+          <a:bodyPr wrap="none">
+            <a:spAutoFit/>
+          </a:bodyPr>
+          <a:lstStyle/>
+          <a:p>
+            <a:pPr algn="r"/>
+            <a:r>
+              <a:rPr sz="800" b="0" i="0">
+                <a:latin typeface="Calibri"/>
+              </a:rPr>
+              <a:t>8/15</a:t>
             </a:r>
           </a:p>
         </p:txBody>
@@ -4143,93 +6459,216 @@
       <p:grpSpPr/>
       <p:sp>
         <p:nvSpPr>
-          <p:cNvPr id="2" name="Title 1"/>
-          <p:cNvSpPr>
-            <a:spLocks noGrp="1"/>
-          </p:cNvSpPr>
-          <p:nvPr>
-            <p:ph type="title"/>
-          </p:nvPr>
-        </p:nvSpPr>
-        <p:spPr/>
-        <p:txBody>
-          <a:bodyPr/>
-          <a:lstStyle/>
-          <a:p>
-            <a:r>
-              <a:t>Слайд 9: Резултати</a:t>
-            </a:r>
-          </a:p>
-        </p:txBody>
-      </p:sp>
-      <p:sp>
-        <p:nvSpPr>
-          <p:cNvPr id="3" name="Content Placeholder 2"/>
-          <p:cNvSpPr>
-            <a:spLocks noGrp="1"/>
-          </p:cNvSpPr>
-          <p:nvPr>
-            <p:ph idx="1"/>
-          </p:nvPr>
-        </p:nvSpPr>
-        <p:spPr/>
-        <p:txBody>
-          <a:bodyPr/>
+          <p:cNvPr id="2" name="TextBox 1"/>
+          <p:cNvSpPr txBox="1"/>
+          <p:nvPr/>
+        </p:nvSpPr>
+        <p:spPr>
+          <a:xfrm>
+            <a:off x="640080" y="411480"/>
+            <a:ext cx="10972800" cy="502920"/>
+          </a:xfrm>
+          <a:prstGeom prst="rect">
+            <a:avLst/>
+          </a:prstGeom>
+          <a:noFill/>
+        </p:spPr>
+        <p:txBody>
+          <a:bodyPr wrap="none">
+            <a:spAutoFit/>
+          </a:bodyPr>
+          <a:lstStyle/>
+          <a:p>
+            <a:pPr algn="l"/>
+            <a:r>
+              <a:rPr sz="2600" b="1" i="0">
+                <a:latin typeface="Calibri"/>
+              </a:rPr>
+              <a:t>Архитектура на модела</a:t>
+            </a:r>
+          </a:p>
+        </p:txBody>
+      </p:sp>
+      <p:sp>
+        <p:nvSpPr>
+          <p:cNvPr id="3" name="Rectangle 2"/>
+          <p:cNvSpPr/>
+          <p:nvPr/>
+        </p:nvSpPr>
+        <p:spPr>
+          <a:xfrm>
+            <a:off x="640080" y="1005840"/>
+            <a:ext cx="10881360" cy="9144"/>
+          </a:xfrm>
+          <a:prstGeom prst="rect">
+            <a:avLst/>
+          </a:prstGeom>
+          <a:solidFill>
+            <a:srgbClr val="000000"/>
+          </a:solidFill>
+          <a:ln>
+            <a:solidFill>
+              <a:srgbClr val="000000"/>
+            </a:solidFill>
+          </a:ln>
+        </p:spPr>
+        <p:style>
+          <a:lnRef idx="1">
+            <a:schemeClr val="accent1"/>
+          </a:lnRef>
+          <a:fillRef idx="3">
+            <a:schemeClr val="accent1"/>
+          </a:fillRef>
+          <a:effectRef idx="2">
+            <a:schemeClr val="accent1"/>
+          </a:effectRef>
+          <a:fontRef idx="minor">
+            <a:schemeClr val="lt1"/>
+          </a:fontRef>
+        </p:style>
+        <p:txBody>
+          <a:bodyPr rtlCol="0" anchor="ctr"/>
+          <a:lstStyle/>
+          <a:p>
+            <a:pPr algn="ctr"/>
+          </a:p>
+        </p:txBody>
+      </p:sp>
+      <p:sp>
+        <p:nvSpPr>
+          <p:cNvPr id="4" name="TextBox 3"/>
+          <p:cNvSpPr txBox="1"/>
+          <p:nvPr/>
+        </p:nvSpPr>
+        <p:spPr>
+          <a:xfrm>
+            <a:off x="868680" y="1325880"/>
+            <a:ext cx="10424160" cy="4754880"/>
+          </a:xfrm>
+          <a:prstGeom prst="rect">
+            <a:avLst/>
+          </a:prstGeom>
+          <a:noFill/>
+        </p:spPr>
+        <p:txBody>
+          <a:bodyPr wrap="square">
+            <a:spAutoFit/>
+          </a:bodyPr>
           <a:lstStyle/>
           <a:p>
             <a:pPr>
-              <a:defRPr sz="2400"/>
+              <a:spcAft>
+                <a:spcPts val="1000"/>
+              </a:spcAft>
+              <a:defRPr sz="2100">
+                <a:latin typeface="Calibri"/>
+              </a:defRPr>
             </a:pPr>
             <a:r>
-              <a:t>Validation loss: `2.7857`.</a:t>
+              <a:t>Encoder: предварително обучен VGG16, използван за извличане на визуални характеристики.</a:t>
             </a:r>
           </a:p>
           <a:p>
             <a:pPr>
-              <a:defRPr sz="2400"/>
+              <a:spcAft>
+                <a:spcPts val="1000"/>
+              </a:spcAft>
+              <a:defRPr sz="2100">
+                <a:latin typeface="Calibri"/>
+              </a:defRPr>
             </a:pPr>
             <a:r>
-              <a:t>Test loss: `2.7643`.</a:t>
+              <a:t>Decoder: LSTM, който получава image features и генерира последователност от думи.</a:t>
             </a:r>
           </a:p>
           <a:p>
             <a:pPr>
-              <a:defRPr sz="2400"/>
+              <a:spcAft>
+                <a:spcPts val="1000"/>
+              </a:spcAft>
+              <a:defRPr sz="2100">
+                <a:latin typeface="Calibri"/>
+              </a:defRPr>
             </a:pPr>
             <a:r>
-              <a:t>BLEU-1: `0.5386`.</a:t>
+              <a:t>Loss функция: cross-entropy за предсказване на следващата дума.</a:t>
             </a:r>
           </a:p>
           <a:p>
             <a:pPr>
-              <a:defRPr sz="2400"/>
+              <a:spcAft>
+                <a:spcPts val="1000"/>
+              </a:spcAft>
+              <a:defRPr sz="2100">
+                <a:latin typeface="Calibri"/>
+              </a:defRPr>
             </a:pPr>
             <a:r>
-              <a:t>BLEU-4: `0.1392`.</a:t>
-            </a:r>
-          </a:p>
-          <a:p>
-            <a:pPr>
-              <a:defRPr sz="2400"/>
-            </a:pPr>
-            <a:r>
-              <a:t>ROUGE-L: `0.3918`.</a:t>
-            </a:r>
-          </a:p>
-          <a:p>
-            <a:pPr>
-              <a:defRPr sz="2400"/>
-            </a:pPr>
-            <a:r>
-              <a:t>Генерираните captions са запазени в `reports/model/generated_captions.csv`.</a:t>
-            </a:r>
-          </a:p>
-          <a:p>
-            <a:pPr>
-              <a:defRPr sz="2400"/>
-            </a:pPr>
-            <a:r>
-              <a:t>Architecture experiments показаха, че hidden size 512 е най-добър от тестваните кратки варианти.</a:t>
+              <a:t>VGG features се кешират, за да се ускори обучението при повторни експерименти.</a:t>
+            </a:r>
+          </a:p>
+        </p:txBody>
+      </p:sp>
+      <p:sp>
+        <p:nvSpPr>
+          <p:cNvPr id="5" name="TextBox 4"/>
+          <p:cNvSpPr txBox="1"/>
+          <p:nvPr/>
+        </p:nvSpPr>
+        <p:spPr>
+          <a:xfrm>
+            <a:off x="548640" y="6473952"/>
+            <a:ext cx="5486400" cy="228600"/>
+          </a:xfrm>
+          <a:prstGeom prst="rect">
+            <a:avLst/>
+          </a:prstGeom>
+          <a:noFill/>
+        </p:spPr>
+        <p:txBody>
+          <a:bodyPr wrap="none">
+            <a:spAutoFit/>
+          </a:bodyPr>
+          <a:lstStyle/>
+          <a:p>
+            <a:pPr algn="l"/>
+            <a:r>
+              <a:rPr sz="800" b="0" i="1">
+                <a:latin typeface="Calibri"/>
+              </a:rPr>
+              <a:t>Генериране на описание за изображение</a:t>
+            </a:r>
+          </a:p>
+        </p:txBody>
+      </p:sp>
+      <p:sp>
+        <p:nvSpPr>
+          <p:cNvPr id="6" name="TextBox 5"/>
+          <p:cNvSpPr txBox="1"/>
+          <p:nvPr/>
+        </p:nvSpPr>
+        <p:spPr>
+          <a:xfrm>
+            <a:off x="10972800" y="6473952"/>
+            <a:ext cx="640080" cy="228600"/>
+          </a:xfrm>
+          <a:prstGeom prst="rect">
+            <a:avLst/>
+          </a:prstGeom>
+          <a:noFill/>
+        </p:spPr>
+        <p:txBody>
+          <a:bodyPr wrap="none">
+            <a:spAutoFit/>
+          </a:bodyPr>
+          <a:lstStyle/>
+          <a:p>
+            <a:pPr algn="r"/>
+            <a:r>
+              <a:rPr sz="800" b="0" i="0">
+                <a:latin typeface="Calibri"/>
+              </a:rPr>
+              <a:t>9/15</a:t>
             </a:r>
           </a:p>
         </p:txBody>

</xml_diff>